<commit_message>
Regenerate Day4 PPT (Deep Blue Academic style)
</commit_message>
<xml_diff>
--- a/ppt/2026-05-13_genetics_day004.pptx
+++ b/ppt/2026-05-13_genetics_day004.pptx
@@ -1836,7 +1836,7 @@
     <p:bg>
       <p:bgPr>
         <a:solidFill>
-          <a:srgbClr val="2C5F2D"/>
+          <a:srgbClr val="003087"/>
         </a:solidFill>
       </p:bgPr>
     </p:bg>
@@ -1869,7 +1869,7 @@
             <a:avLst/>
           </a:prstGeom>
           <a:solidFill>
-            <a:srgbClr val="D4A843"/>
+            <a:srgbClr val="E67E22"/>
           </a:solidFill>
           <a:ln/>
         </p:spPr>
@@ -1940,7 +1940,7 @@
             <a:r>
               <a:rPr lang="en-US" sz="1800" dirty="0">
                 <a:solidFill>
-                  <a:srgbClr val="97BC62"/>
+                  <a:srgbClr val="666666"/>
                 </a:solidFill>
                 <a:latin typeface="Calibri" pitchFamily="34" charset="0"/>
                 <a:ea typeface="Calibri" pitchFamily="34" charset="-122"/>
@@ -2005,7 +2005,7 @@
     <p:bg>
       <p:bgPr>
         <a:solidFill>
-          <a:srgbClr val="FAF8F0"/>
+          <a:srgbClr val="F5F5F5"/>
         </a:solidFill>
       </p:bgPr>
     </p:bg>
@@ -2050,7 +2050,7 @@
             <a:r>
               <a:rPr lang="en-US" sz="2600" b="1" dirty="0">
                 <a:solidFill>
-                  <a:srgbClr val="2C5F2D"/>
+                  <a:srgbClr val="003087"/>
                 </a:solidFill>
                 <a:latin typeface="Georgia" pitchFamily="34" charset="0"/>
                 <a:ea typeface="Georgia" pitchFamily="34" charset="-122"/>
@@ -2077,7 +2077,7 @@
             <a:avLst/>
           </a:prstGeom>
           <a:solidFill>
-            <a:srgbClr val="D4A843"/>
+            <a:srgbClr val="E67E22"/>
           </a:solidFill>
           <a:ln/>
         </p:spPr>
@@ -2096,7 +2096,7 @@
     <p:bg>
       <p:bgPr>
         <a:solidFill>
-          <a:srgbClr val="FAF8F0"/>
+          <a:srgbClr val="F5F5F5"/>
         </a:solidFill>
       </p:bgPr>
     </p:bg>
@@ -2141,7 +2141,7 @@
             <a:r>
               <a:rPr lang="en-US" sz="2600" b="1" dirty="0">
                 <a:solidFill>
-                  <a:srgbClr val="2C5F2D"/>
+                  <a:srgbClr val="003087"/>
                 </a:solidFill>
                 <a:latin typeface="Georgia" pitchFamily="34" charset="0"/>
                 <a:ea typeface="Georgia" pitchFamily="34" charset="-122"/>
@@ -2168,7 +2168,7 @@
             <a:avLst/>
           </a:prstGeom>
           <a:solidFill>
-            <a:srgbClr val="D4A843"/>
+            <a:srgbClr val="E67E22"/>
           </a:solidFill>
           <a:ln/>
         </p:spPr>
@@ -2190,7 +2190,7 @@
             </a:avLst>
           </a:prstGeom>
           <a:solidFill>
-            <a:srgbClr val="2C5F2D"/>
+            <a:srgbClr val="003087"/>
           </a:solidFill>
           <a:ln/>
         </p:spPr>
@@ -2251,7 +2251,7 @@
             </a:avLst>
           </a:prstGeom>
           <a:solidFill>
-            <a:srgbClr val="2C5F2D"/>
+            <a:srgbClr val="003087"/>
           </a:solidFill>
           <a:ln/>
         </p:spPr>
@@ -2309,7 +2309,7 @@
     <p:bg>
       <p:bgPr>
         <a:solidFill>
-          <a:srgbClr val="2C5F2D"/>
+          <a:srgbClr val="003087"/>
         </a:solidFill>
       </p:bgPr>
     </p:bg>
@@ -2342,7 +2342,7 @@
             <a:avLst/>
           </a:prstGeom>
           <a:solidFill>
-            <a:srgbClr val="D4A843"/>
+            <a:srgbClr val="E67E22"/>
           </a:solidFill>
           <a:ln/>
         </p:spPr>
@@ -2413,7 +2413,7 @@
             <a:r>
               <a:rPr lang="en-US" sz="2000" dirty="0">
                 <a:solidFill>
-                  <a:srgbClr val="97BC62"/>
+                  <a:srgbClr val="666666"/>
                 </a:solidFill>
                 <a:latin typeface="Calibri" pitchFamily="34" charset="0"/>
                 <a:ea typeface="Calibri" pitchFamily="34" charset="-122"/>
@@ -2478,7 +2478,7 @@
     <p:bg>
       <p:bgPr>
         <a:solidFill>
-          <a:srgbClr val="FAF8F0"/>
+          <a:srgbClr val="F5F5F5"/>
         </a:solidFill>
       </p:bgPr>
     </p:bg>
@@ -2523,7 +2523,7 @@
             <a:r>
               <a:rPr lang="en-US" sz="2800" b="1" dirty="0">
                 <a:solidFill>
-                  <a:srgbClr val="2C5F2D"/>
+                  <a:srgbClr val="003087"/>
                 </a:solidFill>
                 <a:latin typeface="Georgia" pitchFamily="34" charset="0"/>
                 <a:ea typeface="Georgia" pitchFamily="34" charset="-122"/>
@@ -2550,7 +2550,7 @@
             <a:avLst/>
           </a:prstGeom>
           <a:solidFill>
-            <a:srgbClr val="D4A843"/>
+            <a:srgbClr val="E67E22"/>
           </a:solidFill>
           <a:ln/>
         </p:spPr>
@@ -2570,7 +2570,7 @@
             <a:avLst/>
           </a:prstGeom>
           <a:solidFill>
-            <a:srgbClr val="2C5F2D"/>
+            <a:srgbClr val="003087"/>
           </a:solidFill>
           <a:ln/>
         </p:spPr>
@@ -2668,7 +2668,7 @@
             <a:avLst/>
           </a:prstGeom>
           <a:solidFill>
-            <a:srgbClr val="2C5F2D"/>
+            <a:srgbClr val="003087"/>
           </a:solidFill>
           <a:ln/>
         </p:spPr>
@@ -2766,7 +2766,7 @@
             <a:avLst/>
           </a:prstGeom>
           <a:solidFill>
-            <a:srgbClr val="2C5F2D"/>
+            <a:srgbClr val="003087"/>
           </a:solidFill>
           <a:ln/>
         </p:spPr>
@@ -2864,7 +2864,7 @@
             <a:avLst/>
           </a:prstGeom>
           <a:solidFill>
-            <a:srgbClr val="2C5F2D"/>
+            <a:srgbClr val="003087"/>
           </a:solidFill>
           <a:ln/>
         </p:spPr>
@@ -2962,7 +2962,7 @@
             <a:avLst/>
           </a:prstGeom>
           <a:solidFill>
-            <a:srgbClr val="2C5F2D"/>
+            <a:srgbClr val="003087"/>
           </a:solidFill>
           <a:ln/>
         </p:spPr>
@@ -3060,7 +3060,7 @@
             <a:avLst/>
           </a:prstGeom>
           <a:solidFill>
-            <a:srgbClr val="2C5F2D"/>
+            <a:srgbClr val="003087"/>
           </a:solidFill>
           <a:ln/>
         </p:spPr>
@@ -3158,7 +3158,7 @@
             <a:avLst/>
           </a:prstGeom>
           <a:solidFill>
-            <a:srgbClr val="2C5F2D"/>
+            <a:srgbClr val="003087"/>
           </a:solidFill>
           <a:ln/>
         </p:spPr>
@@ -3256,7 +3256,7 @@
             <a:avLst/>
           </a:prstGeom>
           <a:solidFill>
-            <a:srgbClr val="2C5F2D"/>
+            <a:srgbClr val="003087"/>
           </a:solidFill>
           <a:ln/>
         </p:spPr>
@@ -3353,7 +3353,7 @@
     <p:bg>
       <p:bgPr>
         <a:solidFill>
-          <a:srgbClr val="FAF8F0"/>
+          <a:srgbClr val="F5F5F5"/>
         </a:solidFill>
       </p:bgPr>
     </p:bg>
@@ -3398,7 +3398,7 @@
             <a:r>
               <a:rPr lang="en-US" sz="2600" b="1" dirty="0">
                 <a:solidFill>
-                  <a:srgbClr val="2C5F2D"/>
+                  <a:srgbClr val="003087"/>
                 </a:solidFill>
                 <a:latin typeface="Georgia" pitchFamily="34" charset="0"/>
                 <a:ea typeface="Georgia" pitchFamily="34" charset="-122"/>
@@ -3425,7 +3425,7 @@
             <a:avLst/>
           </a:prstGeom>
           <a:solidFill>
-            <a:srgbClr val="D4A843"/>
+            <a:srgbClr val="E67E22"/>
           </a:solidFill>
           <a:ln/>
         </p:spPr>
@@ -3444,7 +3444,7 @@
     <p:bg>
       <p:bgPr>
         <a:solidFill>
-          <a:srgbClr val="FAF8F0"/>
+          <a:srgbClr val="F5F5F5"/>
         </a:solidFill>
       </p:bgPr>
     </p:bg>
@@ -3489,7 +3489,7 @@
             <a:r>
               <a:rPr lang="en-US" sz="2600" b="1" dirty="0">
                 <a:solidFill>
-                  <a:srgbClr val="2C5F2D"/>
+                  <a:srgbClr val="003087"/>
                 </a:solidFill>
                 <a:latin typeface="Georgia" pitchFamily="34" charset="0"/>
                 <a:ea typeface="Georgia" pitchFamily="34" charset="-122"/>
@@ -3516,7 +3516,7 @@
             <a:avLst/>
           </a:prstGeom>
           <a:solidFill>
-            <a:srgbClr val="D4A843"/>
+            <a:srgbClr val="E67E22"/>
           </a:solidFill>
           <a:ln/>
         </p:spPr>
@@ -3538,7 +3538,7 @@
             </a:avLst>
           </a:prstGeom>
           <a:solidFill>
-            <a:srgbClr val="D5D0C4"/>
+            <a:srgbClr val="DDDDDD"/>
           </a:solidFill>
           <a:ln/>
         </p:spPr>
@@ -3580,7 +3580,7 @@
             <a:avLst/>
           </a:prstGeom>
           <a:solidFill>
-            <a:srgbClr val="2C5F2D"/>
+            <a:srgbClr val="003087"/>
           </a:solidFill>
           <a:ln/>
         </p:spPr>
@@ -3600,7 +3600,7 @@
             <a:avLst/>
           </a:prstGeom>
           <a:solidFill>
-            <a:srgbClr val="2C5F2D"/>
+            <a:srgbClr val="003087"/>
           </a:solidFill>
           <a:ln/>
         </p:spPr>
@@ -3700,7 +3700,7 @@
             </a:avLst>
           </a:prstGeom>
           <a:solidFill>
-            <a:srgbClr val="D5D0C4"/>
+            <a:srgbClr val="DDDDDD"/>
           </a:solidFill>
           <a:ln/>
         </p:spPr>
@@ -3742,7 +3742,7 @@
             <a:avLst/>
           </a:prstGeom>
           <a:solidFill>
-            <a:srgbClr val="2C5F2D"/>
+            <a:srgbClr val="003087"/>
           </a:solidFill>
           <a:ln/>
         </p:spPr>
@@ -3762,7 +3762,7 @@
             <a:avLst/>
           </a:prstGeom>
           <a:solidFill>
-            <a:srgbClr val="2C5F2D"/>
+            <a:srgbClr val="003087"/>
           </a:solidFill>
           <a:ln/>
         </p:spPr>
@@ -3862,7 +3862,7 @@
             </a:avLst>
           </a:prstGeom>
           <a:solidFill>
-            <a:srgbClr val="D5D0C4"/>
+            <a:srgbClr val="DDDDDD"/>
           </a:solidFill>
           <a:ln/>
         </p:spPr>
@@ -3904,7 +3904,7 @@
             <a:avLst/>
           </a:prstGeom>
           <a:solidFill>
-            <a:srgbClr val="2C5F2D"/>
+            <a:srgbClr val="003087"/>
           </a:solidFill>
           <a:ln/>
         </p:spPr>
@@ -3924,7 +3924,7 @@
             <a:avLst/>
           </a:prstGeom>
           <a:solidFill>
-            <a:srgbClr val="2C5F2D"/>
+            <a:srgbClr val="003087"/>
           </a:solidFill>
           <a:ln/>
         </p:spPr>
@@ -4024,7 +4024,7 @@
             </a:avLst>
           </a:prstGeom>
           <a:solidFill>
-            <a:srgbClr val="D5D0C4"/>
+            <a:srgbClr val="DDDDDD"/>
           </a:solidFill>
           <a:ln/>
         </p:spPr>
@@ -4066,7 +4066,7 @@
             <a:avLst/>
           </a:prstGeom>
           <a:solidFill>
-            <a:srgbClr val="2C5F2D"/>
+            <a:srgbClr val="003087"/>
           </a:solidFill>
           <a:ln/>
         </p:spPr>
@@ -4086,7 +4086,7 @@
             <a:avLst/>
           </a:prstGeom>
           <a:solidFill>
-            <a:srgbClr val="2C5F2D"/>
+            <a:srgbClr val="003087"/>
           </a:solidFill>
           <a:ln/>
         </p:spPr>
@@ -4186,7 +4186,7 @@
             </a:avLst>
           </a:prstGeom>
           <a:solidFill>
-            <a:srgbClr val="2C5F2D"/>
+            <a:srgbClr val="003087"/>
           </a:solidFill>
           <a:ln/>
         </p:spPr>
@@ -4247,7 +4247,7 @@
             </a:avLst>
           </a:prstGeom>
           <a:solidFill>
-            <a:srgbClr val="2C5F2D"/>
+            <a:srgbClr val="003087"/>
           </a:solidFill>
           <a:ln/>
         </p:spPr>
@@ -4329,7 +4329,7 @@
     <p:bg>
       <p:bgPr>
         <a:solidFill>
-          <a:srgbClr val="FAF8F0"/>
+          <a:srgbClr val="F5F5F5"/>
         </a:solidFill>
       </p:bgPr>
     </p:bg>
@@ -4374,7 +4374,7 @@
             <a:r>
               <a:rPr lang="en-US" sz="2600" b="1" dirty="0">
                 <a:solidFill>
-                  <a:srgbClr val="2C5F2D"/>
+                  <a:srgbClr val="003087"/>
                 </a:solidFill>
                 <a:latin typeface="Georgia" pitchFamily="34" charset="0"/>
                 <a:ea typeface="Georgia" pitchFamily="34" charset="-122"/>
@@ -4401,7 +4401,7 @@
             <a:avLst/>
           </a:prstGeom>
           <a:solidFill>
-            <a:srgbClr val="D4A843"/>
+            <a:srgbClr val="E67E22"/>
           </a:solidFill>
           <a:ln/>
         </p:spPr>
@@ -4423,7 +4423,7 @@
             </a:avLst>
           </a:prstGeom>
           <a:solidFill>
-            <a:srgbClr val="D5D0C4"/>
+            <a:srgbClr val="DDDDDD"/>
           </a:solidFill>
           <a:ln/>
         </p:spPr>
@@ -4465,7 +4465,7 @@
             <a:avLst/>
           </a:prstGeom>
           <a:solidFill>
-            <a:srgbClr val="2C5F2D"/>
+            <a:srgbClr val="003087"/>
           </a:solidFill>
           <a:ln/>
         </p:spPr>
@@ -4485,7 +4485,7 @@
             <a:avLst/>
           </a:prstGeom>
           <a:solidFill>
-            <a:srgbClr val="2C5F2D"/>
+            <a:srgbClr val="003087"/>
           </a:solidFill>
           <a:ln/>
         </p:spPr>
@@ -4585,7 +4585,7 @@
             </a:avLst>
           </a:prstGeom>
           <a:solidFill>
-            <a:srgbClr val="D5D0C4"/>
+            <a:srgbClr val="DDDDDD"/>
           </a:solidFill>
           <a:ln/>
         </p:spPr>
@@ -4627,7 +4627,7 @@
             <a:avLst/>
           </a:prstGeom>
           <a:solidFill>
-            <a:srgbClr val="2C5F2D"/>
+            <a:srgbClr val="003087"/>
           </a:solidFill>
           <a:ln/>
         </p:spPr>
@@ -4647,7 +4647,7 @@
             <a:avLst/>
           </a:prstGeom>
           <a:solidFill>
-            <a:srgbClr val="2C5F2D"/>
+            <a:srgbClr val="003087"/>
           </a:solidFill>
           <a:ln/>
         </p:spPr>
@@ -4747,7 +4747,7 @@
             </a:avLst>
           </a:prstGeom>
           <a:solidFill>
-            <a:srgbClr val="D5D0C4"/>
+            <a:srgbClr val="DDDDDD"/>
           </a:solidFill>
           <a:ln/>
         </p:spPr>
@@ -4789,7 +4789,7 @@
             <a:avLst/>
           </a:prstGeom>
           <a:solidFill>
-            <a:srgbClr val="2C5F2D"/>
+            <a:srgbClr val="003087"/>
           </a:solidFill>
           <a:ln/>
         </p:spPr>
@@ -4809,7 +4809,7 @@
             <a:avLst/>
           </a:prstGeom>
           <a:solidFill>
-            <a:srgbClr val="2C5F2D"/>
+            <a:srgbClr val="003087"/>
           </a:solidFill>
           <a:ln/>
         </p:spPr>
@@ -4909,7 +4909,7 @@
             </a:avLst>
           </a:prstGeom>
           <a:solidFill>
-            <a:srgbClr val="D5D0C4"/>
+            <a:srgbClr val="DDDDDD"/>
           </a:solidFill>
           <a:ln/>
         </p:spPr>
@@ -4951,7 +4951,7 @@
             <a:avLst/>
           </a:prstGeom>
           <a:solidFill>
-            <a:srgbClr val="2C5F2D"/>
+            <a:srgbClr val="003087"/>
           </a:solidFill>
           <a:ln/>
         </p:spPr>
@@ -4971,7 +4971,7 @@
             <a:avLst/>
           </a:prstGeom>
           <a:solidFill>
-            <a:srgbClr val="2C5F2D"/>
+            <a:srgbClr val="003087"/>
           </a:solidFill>
           <a:ln/>
         </p:spPr>
@@ -5071,7 +5071,7 @@
             </a:avLst>
           </a:prstGeom>
           <a:solidFill>
-            <a:srgbClr val="2C5F2D"/>
+            <a:srgbClr val="003087"/>
           </a:solidFill>
           <a:ln/>
         </p:spPr>
@@ -5132,7 +5132,7 @@
             </a:avLst>
           </a:prstGeom>
           <a:solidFill>
-            <a:srgbClr val="2C5F2D"/>
+            <a:srgbClr val="003087"/>
           </a:solidFill>
           <a:ln/>
         </p:spPr>
@@ -5190,7 +5190,7 @@
     <p:bg>
       <p:bgPr>
         <a:solidFill>
-          <a:srgbClr val="FAF8F0"/>
+          <a:srgbClr val="F5F5F5"/>
         </a:solidFill>
       </p:bgPr>
     </p:bg>
@@ -5235,7 +5235,7 @@
             <a:r>
               <a:rPr lang="en-US" sz="2600" b="1" dirty="0">
                 <a:solidFill>
-                  <a:srgbClr val="2C5F2D"/>
+                  <a:srgbClr val="003087"/>
                 </a:solidFill>
                 <a:latin typeface="Georgia" pitchFamily="34" charset="0"/>
                 <a:ea typeface="Georgia" pitchFamily="34" charset="-122"/>
@@ -5262,7 +5262,7 @@
             <a:avLst/>
           </a:prstGeom>
           <a:solidFill>
-            <a:srgbClr val="D4A843"/>
+            <a:srgbClr val="E67E22"/>
           </a:solidFill>
           <a:ln/>
         </p:spPr>
@@ -5281,7 +5281,7 @@
     <p:bg>
       <p:bgPr>
         <a:solidFill>
-          <a:srgbClr val="FAF8F0"/>
+          <a:srgbClr val="F5F5F5"/>
         </a:solidFill>
       </p:bgPr>
     </p:bg>
@@ -5326,7 +5326,7 @@
             <a:r>
               <a:rPr lang="en-US" sz="2600" b="1" dirty="0">
                 <a:solidFill>
-                  <a:srgbClr val="2C5F2D"/>
+                  <a:srgbClr val="003087"/>
                 </a:solidFill>
                 <a:latin typeface="Georgia" pitchFamily="34" charset="0"/>
                 <a:ea typeface="Georgia" pitchFamily="34" charset="-122"/>
@@ -5353,7 +5353,7 @@
             <a:avLst/>
           </a:prstGeom>
           <a:solidFill>
-            <a:srgbClr val="D4A843"/>
+            <a:srgbClr val="E67E22"/>
           </a:solidFill>
           <a:ln/>
         </p:spPr>
@@ -5375,7 +5375,7 @@
             </a:avLst>
           </a:prstGeom>
           <a:solidFill>
-            <a:srgbClr val="D5D0C4"/>
+            <a:srgbClr val="DDDDDD"/>
           </a:solidFill>
           <a:ln/>
         </p:spPr>
@@ -5417,7 +5417,7 @@
             <a:avLst/>
           </a:prstGeom>
           <a:solidFill>
-            <a:srgbClr val="2C5F2D"/>
+            <a:srgbClr val="003087"/>
           </a:solidFill>
           <a:ln/>
         </p:spPr>
@@ -5437,7 +5437,7 @@
             <a:avLst/>
           </a:prstGeom>
           <a:solidFill>
-            <a:srgbClr val="2C5F2D"/>
+            <a:srgbClr val="003087"/>
           </a:solidFill>
           <a:ln/>
         </p:spPr>
@@ -5537,7 +5537,7 @@
             </a:avLst>
           </a:prstGeom>
           <a:solidFill>
-            <a:srgbClr val="D5D0C4"/>
+            <a:srgbClr val="DDDDDD"/>
           </a:solidFill>
           <a:ln/>
         </p:spPr>
@@ -5579,7 +5579,7 @@
             <a:avLst/>
           </a:prstGeom>
           <a:solidFill>
-            <a:srgbClr val="2C5F2D"/>
+            <a:srgbClr val="003087"/>
           </a:solidFill>
           <a:ln/>
         </p:spPr>
@@ -5599,7 +5599,7 @@
             <a:avLst/>
           </a:prstGeom>
           <a:solidFill>
-            <a:srgbClr val="2C5F2D"/>
+            <a:srgbClr val="003087"/>
           </a:solidFill>
           <a:ln/>
         </p:spPr>
@@ -5699,7 +5699,7 @@
             </a:avLst>
           </a:prstGeom>
           <a:solidFill>
-            <a:srgbClr val="D5D0C4"/>
+            <a:srgbClr val="DDDDDD"/>
           </a:solidFill>
           <a:ln/>
         </p:spPr>
@@ -5741,7 +5741,7 @@
             <a:avLst/>
           </a:prstGeom>
           <a:solidFill>
-            <a:srgbClr val="2C5F2D"/>
+            <a:srgbClr val="003087"/>
           </a:solidFill>
           <a:ln/>
         </p:spPr>
@@ -5761,7 +5761,7 @@
             <a:avLst/>
           </a:prstGeom>
           <a:solidFill>
-            <a:srgbClr val="2C5F2D"/>
+            <a:srgbClr val="003087"/>
           </a:solidFill>
           <a:ln/>
         </p:spPr>
@@ -5861,7 +5861,7 @@
             </a:avLst>
           </a:prstGeom>
           <a:solidFill>
-            <a:srgbClr val="D5D0C4"/>
+            <a:srgbClr val="DDDDDD"/>
           </a:solidFill>
           <a:ln/>
         </p:spPr>
@@ -5903,7 +5903,7 @@
             <a:avLst/>
           </a:prstGeom>
           <a:solidFill>
-            <a:srgbClr val="2C5F2D"/>
+            <a:srgbClr val="003087"/>
           </a:solidFill>
           <a:ln/>
         </p:spPr>
@@ -5923,7 +5923,7 @@
             <a:avLst/>
           </a:prstGeom>
           <a:solidFill>
-            <a:srgbClr val="2C5F2D"/>
+            <a:srgbClr val="003087"/>
           </a:solidFill>
           <a:ln/>
         </p:spPr>
@@ -6020,7 +6020,7 @@
     <p:bg>
       <p:bgPr>
         <a:solidFill>
-          <a:srgbClr val="FAF8F0"/>
+          <a:srgbClr val="F5F5F5"/>
         </a:solidFill>
       </p:bgPr>
     </p:bg>
@@ -6065,7 +6065,7 @@
             <a:r>
               <a:rPr lang="en-US" sz="2600" b="1" dirty="0">
                 <a:solidFill>
-                  <a:srgbClr val="2C5F2D"/>
+                  <a:srgbClr val="003087"/>
                 </a:solidFill>
                 <a:latin typeface="Georgia" pitchFamily="34" charset="0"/>
                 <a:ea typeface="Georgia" pitchFamily="34" charset="-122"/>
@@ -6092,7 +6092,7 @@
             <a:avLst/>
           </a:prstGeom>
           <a:solidFill>
-            <a:srgbClr val="D4A843"/>
+            <a:srgbClr val="E67E22"/>
           </a:solidFill>
           <a:ln/>
         </p:spPr>
@@ -6114,7 +6114,7 @@
             </a:avLst>
           </a:prstGeom>
           <a:solidFill>
-            <a:srgbClr val="2C5F2D"/>
+            <a:srgbClr val="003087"/>
           </a:solidFill>
           <a:ln/>
         </p:spPr>
@@ -6175,7 +6175,7 @@
             </a:avLst>
           </a:prstGeom>
           <a:solidFill>
-            <a:srgbClr val="2C5F2D"/>
+            <a:srgbClr val="003087"/>
           </a:solidFill>
           <a:ln/>
         </p:spPr>
@@ -6233,7 +6233,7 @@
     <p:bg>
       <p:bgPr>
         <a:solidFill>
-          <a:srgbClr val="FAF8F0"/>
+          <a:srgbClr val="F5F5F5"/>
         </a:solidFill>
       </p:bgPr>
     </p:bg>
@@ -6278,7 +6278,7 @@
             <a:r>
               <a:rPr lang="en-US" sz="2600" b="1" dirty="0">
                 <a:solidFill>
-                  <a:srgbClr val="2C5F2D"/>
+                  <a:srgbClr val="003087"/>
                 </a:solidFill>
                 <a:latin typeface="Georgia" pitchFamily="34" charset="0"/>
                 <a:ea typeface="Georgia" pitchFamily="34" charset="-122"/>
@@ -6305,7 +6305,7 @@
             <a:avLst/>
           </a:prstGeom>
           <a:solidFill>
-            <a:srgbClr val="D4A843"/>
+            <a:srgbClr val="E67E22"/>
           </a:solidFill>
           <a:ln/>
         </p:spPr>

</xml_diff>

<commit_message>
Regenerate Day4 PPT (Forest & Moss style)
</commit_message>
<xml_diff>
--- a/ppt/2026-05-13_genetics_day004.pptx
+++ b/ppt/2026-05-13_genetics_day004.pptx
@@ -1836,7 +1836,7 @@
     <p:bg>
       <p:bgPr>
         <a:solidFill>
-          <a:srgbClr val="003087"/>
+          <a:srgbClr val="2D5A27"/>
         </a:solidFill>
       </p:bgPr>
     </p:bg>
@@ -1869,7 +1869,7 @@
             <a:avLst/>
           </a:prstGeom>
           <a:solidFill>
-            <a:srgbClr val="E67E22"/>
+            <a:srgbClr val="D4A574"/>
           </a:solidFill>
           <a:ln/>
         </p:spPr>
@@ -1901,7 +1901,7 @@
             <a:r>
               <a:rPr lang="en-US" sz="4400" b="1" dirty="0">
                 <a:solidFill>
-                  <a:srgbClr val="FFFFFF"/>
+                  <a:srgbClr val="FFFEF9"/>
                 </a:solidFill>
                 <a:latin typeface="Georgia" pitchFamily="34" charset="0"/>
                 <a:ea typeface="Georgia" pitchFamily="34" charset="-122"/>
@@ -1940,7 +1940,7 @@
             <a:r>
               <a:rPr lang="en-US" sz="1800" dirty="0">
                 <a:solidFill>
-                  <a:srgbClr val="666666"/>
+                  <a:srgbClr val="6B6B6B"/>
                 </a:solidFill>
                 <a:latin typeface="Calibri" pitchFamily="34" charset="0"/>
                 <a:ea typeface="Calibri" pitchFamily="34" charset="-122"/>
@@ -1979,7 +1979,7 @@
             <a:r>
               <a:rPr lang="en-US" sz="1400" dirty="0">
                 <a:solidFill>
-                  <a:srgbClr val="FFFFFF"/>
+                  <a:srgbClr val="FFFEF9"/>
                 </a:solidFill>
                 <a:latin typeface="Calibri" pitchFamily="34" charset="0"/>
                 <a:ea typeface="Calibri" pitchFamily="34" charset="-122"/>
@@ -2005,7 +2005,7 @@
     <p:bg>
       <p:bgPr>
         <a:solidFill>
-          <a:srgbClr val="F5F5F5"/>
+          <a:srgbClr val="FDF8F3"/>
         </a:solidFill>
       </p:bgPr>
     </p:bg>
@@ -2050,7 +2050,7 @@
             <a:r>
               <a:rPr lang="en-US" sz="2600" b="1" dirty="0">
                 <a:solidFill>
-                  <a:srgbClr val="003087"/>
+                  <a:srgbClr val="2D5A27"/>
                 </a:solidFill>
                 <a:latin typeface="Georgia" pitchFamily="34" charset="0"/>
                 <a:ea typeface="Georgia" pitchFamily="34" charset="-122"/>
@@ -2077,7 +2077,7 @@
             <a:avLst/>
           </a:prstGeom>
           <a:solidFill>
-            <a:srgbClr val="E67E22"/>
+            <a:srgbClr val="D4A574"/>
           </a:solidFill>
           <a:ln/>
         </p:spPr>
@@ -2096,7 +2096,7 @@
     <p:bg>
       <p:bgPr>
         <a:solidFill>
-          <a:srgbClr val="F5F5F5"/>
+          <a:srgbClr val="FDF8F3"/>
         </a:solidFill>
       </p:bgPr>
     </p:bg>
@@ -2141,7 +2141,7 @@
             <a:r>
               <a:rPr lang="en-US" sz="2600" b="1" dirty="0">
                 <a:solidFill>
-                  <a:srgbClr val="003087"/>
+                  <a:srgbClr val="2D5A27"/>
                 </a:solidFill>
                 <a:latin typeface="Georgia" pitchFamily="34" charset="0"/>
                 <a:ea typeface="Georgia" pitchFamily="34" charset="-122"/>
@@ -2168,7 +2168,7 @@
             <a:avLst/>
           </a:prstGeom>
           <a:solidFill>
-            <a:srgbClr val="E67E22"/>
+            <a:srgbClr val="D4A574"/>
           </a:solidFill>
           <a:ln/>
         </p:spPr>
@@ -2190,7 +2190,7 @@
             </a:avLst>
           </a:prstGeom>
           <a:solidFill>
-            <a:srgbClr val="003087"/>
+            <a:srgbClr val="2D5A27"/>
           </a:solidFill>
           <a:ln/>
         </p:spPr>
@@ -2222,7 +2222,7 @@
             <a:r>
               <a:rPr lang="en-US" sz="1300" i="1" dirty="0">
                 <a:solidFill>
-                  <a:srgbClr val="FFFFFF"/>
+                  <a:srgbClr val="FFFEF9"/>
                 </a:solidFill>
                 <a:latin typeface="Calibri" pitchFamily="34" charset="0"/>
                 <a:ea typeface="Calibri" pitchFamily="34" charset="-122"/>
@@ -2251,7 +2251,7 @@
             </a:avLst>
           </a:prstGeom>
           <a:solidFill>
-            <a:srgbClr val="003087"/>
+            <a:srgbClr val="2D5A27"/>
           </a:solidFill>
           <a:ln/>
         </p:spPr>
@@ -2283,7 +2283,7 @@
             <a:r>
               <a:rPr lang="en-US" sz="1300" i="1" dirty="0">
                 <a:solidFill>
-                  <a:srgbClr val="FFFFFF"/>
+                  <a:srgbClr val="FFFEF9"/>
                 </a:solidFill>
                 <a:latin typeface="Calibri" pitchFamily="34" charset="0"/>
                 <a:ea typeface="Calibri" pitchFamily="34" charset="-122"/>
@@ -2309,7 +2309,7 @@
     <p:bg>
       <p:bgPr>
         <a:solidFill>
-          <a:srgbClr val="003087"/>
+          <a:srgbClr val="2D5A27"/>
         </a:solidFill>
       </p:bgPr>
     </p:bg>
@@ -2342,7 +2342,7 @@
             <a:avLst/>
           </a:prstGeom>
           <a:solidFill>
-            <a:srgbClr val="E67E22"/>
+            <a:srgbClr val="D4A574"/>
           </a:solidFill>
           <a:ln/>
         </p:spPr>
@@ -2374,7 +2374,7 @@
             <a:r>
               <a:rPr lang="en-US" sz="4800" b="1" dirty="0">
                 <a:solidFill>
-                  <a:srgbClr val="FFFFFF"/>
+                  <a:srgbClr val="FFFEF9"/>
                 </a:solidFill>
                 <a:latin typeface="Georgia" pitchFamily="34" charset="0"/>
                 <a:ea typeface="Georgia" pitchFamily="34" charset="-122"/>
@@ -2413,7 +2413,7 @@
             <a:r>
               <a:rPr lang="en-US" sz="2000" dirty="0">
                 <a:solidFill>
-                  <a:srgbClr val="666666"/>
+                  <a:srgbClr val="6B6B6B"/>
                 </a:solidFill>
                 <a:latin typeface="Calibri" pitchFamily="34" charset="0"/>
                 <a:ea typeface="Calibri" pitchFamily="34" charset="-122"/>
@@ -2452,7 +2452,7 @@
             <a:r>
               <a:rPr lang="en-US" sz="1200" dirty="0">
                 <a:solidFill>
-                  <a:srgbClr val="FFFFFF"/>
+                  <a:srgbClr val="FFFEF9"/>
                 </a:solidFill>
                 <a:latin typeface="Calibri" pitchFamily="34" charset="0"/>
                 <a:ea typeface="Calibri" pitchFamily="34" charset="-122"/>
@@ -2478,7 +2478,7 @@
     <p:bg>
       <p:bgPr>
         <a:solidFill>
-          <a:srgbClr val="F5F5F5"/>
+          <a:srgbClr val="FDF8F3"/>
         </a:solidFill>
       </p:bgPr>
     </p:bg>
@@ -2523,7 +2523,7 @@
             <a:r>
               <a:rPr lang="en-US" sz="2800" b="1" dirty="0">
                 <a:solidFill>
-                  <a:srgbClr val="003087"/>
+                  <a:srgbClr val="2D5A27"/>
                 </a:solidFill>
                 <a:latin typeface="Georgia" pitchFamily="34" charset="0"/>
                 <a:ea typeface="Georgia" pitchFamily="34" charset="-122"/>
@@ -2550,7 +2550,7 @@
             <a:avLst/>
           </a:prstGeom>
           <a:solidFill>
-            <a:srgbClr val="E67E22"/>
+            <a:srgbClr val="D4A574"/>
           </a:solidFill>
           <a:ln/>
         </p:spPr>
@@ -2563,14 +2563,14 @@
         </p:nvSpPr>
         <p:spPr>
           <a:xfrm>
-            <a:off x="594360" y="1188720"/>
-            <a:ext cx="365760" cy="365760"/>
+            <a:off x="576072" y="1170432"/>
+            <a:ext cx="402336" cy="402336"/>
           </a:xfrm>
           <a:prstGeom prst="ellipse">
             <a:avLst/>
           </a:prstGeom>
           <a:solidFill>
-            <a:srgbClr val="003087"/>
+            <a:srgbClr val="2D5A27"/>
           </a:solidFill>
           <a:ln/>
         </p:spPr>
@@ -2583,8 +2583,8 @@
         </p:nvSpPr>
         <p:spPr>
           <a:xfrm>
-            <a:off x="594360" y="1188720"/>
-            <a:ext cx="365760" cy="365760"/>
+            <a:off x="576072" y="1170432"/>
+            <a:ext cx="402336" cy="402336"/>
           </a:xfrm>
           <a:prstGeom prst="rect">
             <a:avLst/>
@@ -2600,9 +2600,9 @@
               <a:buNone/>
             </a:pPr>
             <a:r>
-              <a:rPr lang="en-US" sz="1100" b="1" dirty="0">
+              <a:rPr lang="en-US" sz="1200" b="1" dirty="0">
                 <a:solidFill>
-                  <a:srgbClr val="FFFFFF"/>
+                  <a:srgbClr val="FFFEF9"/>
                 </a:solidFill>
                 <a:latin typeface="Calibri" pitchFamily="34" charset="0"/>
                 <a:ea typeface="Calibri" pitchFamily="34" charset="-122"/>
@@ -2610,7 +2610,7 @@
               </a:rPr>
               <a:t>1</a:t>
             </a:r>
-            <a:endParaRPr lang="en-US" sz="1100" dirty="0"/>
+            <a:endParaRPr lang="en-US" sz="1200" dirty="0"/>
           </a:p>
         </p:txBody>
       </p:sp>
@@ -2641,7 +2641,7 @@
             <a:r>
               <a:rPr lang="en-US" sz="1600" dirty="0">
                 <a:solidFill>
-                  <a:srgbClr val="333333"/>
+                  <a:srgbClr val="3D3D3D"/>
                 </a:solidFill>
                 <a:latin typeface="Calibri" pitchFamily="34" charset="0"/>
                 <a:ea typeface="Calibri" pitchFamily="34" charset="-122"/>
@@ -2661,14 +2661,14 @@
         </p:nvSpPr>
         <p:spPr>
           <a:xfrm>
-            <a:off x="594360" y="1645920"/>
-            <a:ext cx="365760" cy="365760"/>
+            <a:off x="576072" y="1627632"/>
+            <a:ext cx="402336" cy="402336"/>
           </a:xfrm>
           <a:prstGeom prst="ellipse">
             <a:avLst/>
           </a:prstGeom>
           <a:solidFill>
-            <a:srgbClr val="003087"/>
+            <a:srgbClr val="2D5A27"/>
           </a:solidFill>
           <a:ln/>
         </p:spPr>
@@ -2681,8 +2681,8 @@
         </p:nvSpPr>
         <p:spPr>
           <a:xfrm>
-            <a:off x="594360" y="1645920"/>
-            <a:ext cx="365760" cy="365760"/>
+            <a:off x="576072" y="1627632"/>
+            <a:ext cx="402336" cy="402336"/>
           </a:xfrm>
           <a:prstGeom prst="rect">
             <a:avLst/>
@@ -2698,9 +2698,9 @@
               <a:buNone/>
             </a:pPr>
             <a:r>
-              <a:rPr lang="en-US" sz="1100" b="1" dirty="0">
+              <a:rPr lang="en-US" sz="1200" b="1" dirty="0">
                 <a:solidFill>
-                  <a:srgbClr val="FFFFFF"/>
+                  <a:srgbClr val="FFFEF9"/>
                 </a:solidFill>
                 <a:latin typeface="Calibri" pitchFamily="34" charset="0"/>
                 <a:ea typeface="Calibri" pitchFamily="34" charset="-122"/>
@@ -2708,7 +2708,7 @@
               </a:rPr>
               <a:t>2</a:t>
             </a:r>
-            <a:endParaRPr lang="en-US" sz="1100" dirty="0"/>
+            <a:endParaRPr lang="en-US" sz="1200" dirty="0"/>
           </a:p>
         </p:txBody>
       </p:sp>
@@ -2739,7 +2739,7 @@
             <a:r>
               <a:rPr lang="en-US" sz="1600" dirty="0">
                 <a:solidFill>
-                  <a:srgbClr val="333333"/>
+                  <a:srgbClr val="3D3D3D"/>
                 </a:solidFill>
                 <a:latin typeface="Calibri" pitchFamily="34" charset="0"/>
                 <a:ea typeface="Calibri" pitchFamily="34" charset="-122"/>
@@ -2759,14 +2759,14 @@
         </p:nvSpPr>
         <p:spPr>
           <a:xfrm>
-            <a:off x="594360" y="2103120"/>
-            <a:ext cx="365760" cy="365760"/>
+            <a:off x="576072" y="2084832"/>
+            <a:ext cx="402336" cy="402336"/>
           </a:xfrm>
           <a:prstGeom prst="ellipse">
             <a:avLst/>
           </a:prstGeom>
           <a:solidFill>
-            <a:srgbClr val="003087"/>
+            <a:srgbClr val="2D5A27"/>
           </a:solidFill>
           <a:ln/>
         </p:spPr>
@@ -2779,8 +2779,8 @@
         </p:nvSpPr>
         <p:spPr>
           <a:xfrm>
-            <a:off x="594360" y="2103120"/>
-            <a:ext cx="365760" cy="365760"/>
+            <a:off x="576072" y="2084832"/>
+            <a:ext cx="402336" cy="402336"/>
           </a:xfrm>
           <a:prstGeom prst="rect">
             <a:avLst/>
@@ -2796,9 +2796,9 @@
               <a:buNone/>
             </a:pPr>
             <a:r>
-              <a:rPr lang="en-US" sz="1100" b="1" dirty="0">
+              <a:rPr lang="en-US" sz="1200" b="1" dirty="0">
                 <a:solidFill>
-                  <a:srgbClr val="FFFFFF"/>
+                  <a:srgbClr val="FFFEF9"/>
                 </a:solidFill>
                 <a:latin typeface="Calibri" pitchFamily="34" charset="0"/>
                 <a:ea typeface="Calibri" pitchFamily="34" charset="-122"/>
@@ -2806,7 +2806,7 @@
               </a:rPr>
               <a:t>3</a:t>
             </a:r>
-            <a:endParaRPr lang="en-US" sz="1100" dirty="0"/>
+            <a:endParaRPr lang="en-US" sz="1200" dirty="0"/>
           </a:p>
         </p:txBody>
       </p:sp>
@@ -2837,7 +2837,7 @@
             <a:r>
               <a:rPr lang="en-US" sz="1600" dirty="0">
                 <a:solidFill>
-                  <a:srgbClr val="333333"/>
+                  <a:srgbClr val="3D3D3D"/>
                 </a:solidFill>
                 <a:latin typeface="Calibri" pitchFamily="34" charset="0"/>
                 <a:ea typeface="Calibri" pitchFamily="34" charset="-122"/>
@@ -2857,14 +2857,14 @@
         </p:nvSpPr>
         <p:spPr>
           <a:xfrm>
-            <a:off x="594360" y="2560320"/>
-            <a:ext cx="365760" cy="365760"/>
+            <a:off x="576072" y="2542032"/>
+            <a:ext cx="402336" cy="402336"/>
           </a:xfrm>
           <a:prstGeom prst="ellipse">
             <a:avLst/>
           </a:prstGeom>
           <a:solidFill>
-            <a:srgbClr val="003087"/>
+            <a:srgbClr val="2D5A27"/>
           </a:solidFill>
           <a:ln/>
         </p:spPr>
@@ -2877,8 +2877,8 @@
         </p:nvSpPr>
         <p:spPr>
           <a:xfrm>
-            <a:off x="594360" y="2560320"/>
-            <a:ext cx="365760" cy="365760"/>
+            <a:off x="576072" y="2542032"/>
+            <a:ext cx="402336" cy="402336"/>
           </a:xfrm>
           <a:prstGeom prst="rect">
             <a:avLst/>
@@ -2894,9 +2894,9 @@
               <a:buNone/>
             </a:pPr>
             <a:r>
-              <a:rPr lang="en-US" sz="1100" b="1" dirty="0">
+              <a:rPr lang="en-US" sz="1200" b="1" dirty="0">
                 <a:solidFill>
-                  <a:srgbClr val="FFFFFF"/>
+                  <a:srgbClr val="FFFEF9"/>
                 </a:solidFill>
                 <a:latin typeface="Calibri" pitchFamily="34" charset="0"/>
                 <a:ea typeface="Calibri" pitchFamily="34" charset="-122"/>
@@ -2904,7 +2904,7 @@
               </a:rPr>
               <a:t>4</a:t>
             </a:r>
-            <a:endParaRPr lang="en-US" sz="1100" dirty="0"/>
+            <a:endParaRPr lang="en-US" sz="1200" dirty="0"/>
           </a:p>
         </p:txBody>
       </p:sp>
@@ -2935,7 +2935,7 @@
             <a:r>
               <a:rPr lang="en-US" sz="1600" dirty="0">
                 <a:solidFill>
-                  <a:srgbClr val="333333"/>
+                  <a:srgbClr val="3D3D3D"/>
                 </a:solidFill>
                 <a:latin typeface="Calibri" pitchFamily="34" charset="0"/>
                 <a:ea typeface="Calibri" pitchFamily="34" charset="-122"/>
@@ -2955,14 +2955,14 @@
         </p:nvSpPr>
         <p:spPr>
           <a:xfrm>
-            <a:off x="594360" y="3017520"/>
-            <a:ext cx="365760" cy="365760"/>
+            <a:off x="576072" y="2999232"/>
+            <a:ext cx="402336" cy="402336"/>
           </a:xfrm>
           <a:prstGeom prst="ellipse">
             <a:avLst/>
           </a:prstGeom>
           <a:solidFill>
-            <a:srgbClr val="003087"/>
+            <a:srgbClr val="2D5A27"/>
           </a:solidFill>
           <a:ln/>
         </p:spPr>
@@ -2975,8 +2975,8 @@
         </p:nvSpPr>
         <p:spPr>
           <a:xfrm>
-            <a:off x="594360" y="3017520"/>
-            <a:ext cx="365760" cy="365760"/>
+            <a:off x="576072" y="2999232"/>
+            <a:ext cx="402336" cy="402336"/>
           </a:xfrm>
           <a:prstGeom prst="rect">
             <a:avLst/>
@@ -2992,9 +2992,9 @@
               <a:buNone/>
             </a:pPr>
             <a:r>
-              <a:rPr lang="en-US" sz="1100" b="1" dirty="0">
+              <a:rPr lang="en-US" sz="1200" b="1" dirty="0">
                 <a:solidFill>
-                  <a:srgbClr val="FFFFFF"/>
+                  <a:srgbClr val="FFFEF9"/>
                 </a:solidFill>
                 <a:latin typeface="Calibri" pitchFamily="34" charset="0"/>
                 <a:ea typeface="Calibri" pitchFamily="34" charset="-122"/>
@@ -3002,7 +3002,7 @@
               </a:rPr>
               <a:t>5</a:t>
             </a:r>
-            <a:endParaRPr lang="en-US" sz="1100" dirty="0"/>
+            <a:endParaRPr lang="en-US" sz="1200" dirty="0"/>
           </a:p>
         </p:txBody>
       </p:sp>
@@ -3033,7 +3033,7 @@
             <a:r>
               <a:rPr lang="en-US" sz="1600" dirty="0">
                 <a:solidFill>
-                  <a:srgbClr val="333333"/>
+                  <a:srgbClr val="3D3D3D"/>
                 </a:solidFill>
                 <a:latin typeface="Calibri" pitchFamily="34" charset="0"/>
                 <a:ea typeface="Calibri" pitchFamily="34" charset="-122"/>
@@ -3053,14 +3053,14 @@
         </p:nvSpPr>
         <p:spPr>
           <a:xfrm>
-            <a:off x="594360" y="3474720"/>
-            <a:ext cx="365760" cy="365760"/>
+            <a:off x="576072" y="3456432"/>
+            <a:ext cx="402336" cy="402336"/>
           </a:xfrm>
           <a:prstGeom prst="ellipse">
             <a:avLst/>
           </a:prstGeom>
           <a:solidFill>
-            <a:srgbClr val="003087"/>
+            <a:srgbClr val="2D5A27"/>
           </a:solidFill>
           <a:ln/>
         </p:spPr>
@@ -3073,8 +3073,8 @@
         </p:nvSpPr>
         <p:spPr>
           <a:xfrm>
-            <a:off x="594360" y="3474720"/>
-            <a:ext cx="365760" cy="365760"/>
+            <a:off x="576072" y="3456432"/>
+            <a:ext cx="402336" cy="402336"/>
           </a:xfrm>
           <a:prstGeom prst="rect">
             <a:avLst/>
@@ -3090,9 +3090,9 @@
               <a:buNone/>
             </a:pPr>
             <a:r>
-              <a:rPr lang="en-US" sz="1100" b="1" dirty="0">
+              <a:rPr lang="en-US" sz="1200" b="1" dirty="0">
                 <a:solidFill>
-                  <a:srgbClr val="FFFFFF"/>
+                  <a:srgbClr val="FFFEF9"/>
                 </a:solidFill>
                 <a:latin typeface="Calibri" pitchFamily="34" charset="0"/>
                 <a:ea typeface="Calibri" pitchFamily="34" charset="-122"/>
@@ -3100,7 +3100,7 @@
               </a:rPr>
               <a:t>6</a:t>
             </a:r>
-            <a:endParaRPr lang="en-US" sz="1100" dirty="0"/>
+            <a:endParaRPr lang="en-US" sz="1200" dirty="0"/>
           </a:p>
         </p:txBody>
       </p:sp>
@@ -3131,7 +3131,7 @@
             <a:r>
               <a:rPr lang="en-US" sz="1600" dirty="0">
                 <a:solidFill>
-                  <a:srgbClr val="333333"/>
+                  <a:srgbClr val="3D3D3D"/>
                 </a:solidFill>
                 <a:latin typeface="Calibri" pitchFamily="34" charset="0"/>
                 <a:ea typeface="Calibri" pitchFamily="34" charset="-122"/>
@@ -3151,14 +3151,14 @@
         </p:nvSpPr>
         <p:spPr>
           <a:xfrm>
-            <a:off x="594360" y="3931920"/>
-            <a:ext cx="365760" cy="365760"/>
+            <a:off x="576072" y="3913632"/>
+            <a:ext cx="402336" cy="402336"/>
           </a:xfrm>
           <a:prstGeom prst="ellipse">
             <a:avLst/>
           </a:prstGeom>
           <a:solidFill>
-            <a:srgbClr val="003087"/>
+            <a:srgbClr val="2D5A27"/>
           </a:solidFill>
           <a:ln/>
         </p:spPr>
@@ -3171,8 +3171,8 @@
         </p:nvSpPr>
         <p:spPr>
           <a:xfrm>
-            <a:off x="594360" y="3931920"/>
-            <a:ext cx="365760" cy="365760"/>
+            <a:off x="576072" y="3913632"/>
+            <a:ext cx="402336" cy="402336"/>
           </a:xfrm>
           <a:prstGeom prst="rect">
             <a:avLst/>
@@ -3188,9 +3188,9 @@
               <a:buNone/>
             </a:pPr>
             <a:r>
-              <a:rPr lang="en-US" sz="1100" b="1" dirty="0">
+              <a:rPr lang="en-US" sz="1200" b="1" dirty="0">
                 <a:solidFill>
-                  <a:srgbClr val="FFFFFF"/>
+                  <a:srgbClr val="FFFEF9"/>
                 </a:solidFill>
                 <a:latin typeface="Calibri" pitchFamily="34" charset="0"/>
                 <a:ea typeface="Calibri" pitchFamily="34" charset="-122"/>
@@ -3198,7 +3198,7 @@
               </a:rPr>
               <a:t>7</a:t>
             </a:r>
-            <a:endParaRPr lang="en-US" sz="1100" dirty="0"/>
+            <a:endParaRPr lang="en-US" sz="1200" dirty="0"/>
           </a:p>
         </p:txBody>
       </p:sp>
@@ -3229,7 +3229,7 @@
             <a:r>
               <a:rPr lang="en-US" sz="1600" dirty="0">
                 <a:solidFill>
-                  <a:srgbClr val="333333"/>
+                  <a:srgbClr val="3D3D3D"/>
                 </a:solidFill>
                 <a:latin typeface="Calibri" pitchFamily="34" charset="0"/>
                 <a:ea typeface="Calibri" pitchFamily="34" charset="-122"/>
@@ -3249,14 +3249,14 @@
         </p:nvSpPr>
         <p:spPr>
           <a:xfrm>
-            <a:off x="594360" y="4389120"/>
-            <a:ext cx="365760" cy="365760"/>
+            <a:off x="576072" y="4370832"/>
+            <a:ext cx="402336" cy="402336"/>
           </a:xfrm>
           <a:prstGeom prst="ellipse">
             <a:avLst/>
           </a:prstGeom>
           <a:solidFill>
-            <a:srgbClr val="003087"/>
+            <a:srgbClr val="2D5A27"/>
           </a:solidFill>
           <a:ln/>
         </p:spPr>
@@ -3269,8 +3269,8 @@
         </p:nvSpPr>
         <p:spPr>
           <a:xfrm>
-            <a:off x="594360" y="4389120"/>
-            <a:ext cx="365760" cy="365760"/>
+            <a:off x="576072" y="4370832"/>
+            <a:ext cx="402336" cy="402336"/>
           </a:xfrm>
           <a:prstGeom prst="rect">
             <a:avLst/>
@@ -3286,9 +3286,9 @@
               <a:buNone/>
             </a:pPr>
             <a:r>
-              <a:rPr lang="en-US" sz="1100" b="1" dirty="0">
+              <a:rPr lang="en-US" sz="1200" b="1" dirty="0">
                 <a:solidFill>
-                  <a:srgbClr val="FFFFFF"/>
+                  <a:srgbClr val="FFFEF9"/>
                 </a:solidFill>
                 <a:latin typeface="Calibri" pitchFamily="34" charset="0"/>
                 <a:ea typeface="Calibri" pitchFamily="34" charset="-122"/>
@@ -3296,7 +3296,7 @@
               </a:rPr>
               <a:t>8</a:t>
             </a:r>
-            <a:endParaRPr lang="en-US" sz="1100" dirty="0"/>
+            <a:endParaRPr lang="en-US" sz="1200" dirty="0"/>
           </a:p>
         </p:txBody>
       </p:sp>
@@ -3327,7 +3327,7 @@
             <a:r>
               <a:rPr lang="en-US" sz="1600" dirty="0">
                 <a:solidFill>
-                  <a:srgbClr val="333333"/>
+                  <a:srgbClr val="3D3D3D"/>
                 </a:solidFill>
                 <a:latin typeface="Calibri" pitchFamily="34" charset="0"/>
                 <a:ea typeface="Calibri" pitchFamily="34" charset="-122"/>
@@ -3353,7 +3353,7 @@
     <p:bg>
       <p:bgPr>
         <a:solidFill>
-          <a:srgbClr val="F5F5F5"/>
+          <a:srgbClr val="FDF8F3"/>
         </a:solidFill>
       </p:bgPr>
     </p:bg>
@@ -3398,7 +3398,7 @@
             <a:r>
               <a:rPr lang="en-US" sz="2600" b="1" dirty="0">
                 <a:solidFill>
-                  <a:srgbClr val="003087"/>
+                  <a:srgbClr val="2D5A27"/>
                 </a:solidFill>
                 <a:latin typeface="Georgia" pitchFamily="34" charset="0"/>
                 <a:ea typeface="Georgia" pitchFamily="34" charset="-122"/>
@@ -3425,7 +3425,7 @@
             <a:avLst/>
           </a:prstGeom>
           <a:solidFill>
-            <a:srgbClr val="E67E22"/>
+            <a:srgbClr val="D4A574"/>
           </a:solidFill>
           <a:ln/>
         </p:spPr>
@@ -3444,7 +3444,7 @@
     <p:bg>
       <p:bgPr>
         <a:solidFill>
-          <a:srgbClr val="F5F5F5"/>
+          <a:srgbClr val="FDF8F3"/>
         </a:solidFill>
       </p:bgPr>
     </p:bg>
@@ -3489,7 +3489,7 @@
             <a:r>
               <a:rPr lang="en-US" sz="2600" b="1" dirty="0">
                 <a:solidFill>
-                  <a:srgbClr val="003087"/>
+                  <a:srgbClr val="2D5A27"/>
                 </a:solidFill>
                 <a:latin typeface="Georgia" pitchFamily="34" charset="0"/>
                 <a:ea typeface="Georgia" pitchFamily="34" charset="-122"/>
@@ -3516,7 +3516,7 @@
             <a:avLst/>
           </a:prstGeom>
           <a:solidFill>
-            <a:srgbClr val="E67E22"/>
+            <a:srgbClr val="D4A574"/>
           </a:solidFill>
           <a:ln/>
         </p:spPr>
@@ -3529,7 +3529,7 @@
         </p:nvSpPr>
         <p:spPr>
           <a:xfrm>
-            <a:off x="576072" y="1033272"/>
+            <a:off x="585216" y="1042416"/>
             <a:ext cx="8046720" cy="685800"/>
           </a:xfrm>
           <a:prstGeom prst="roundRect">
@@ -3538,7 +3538,7 @@
             </a:avLst>
           </a:prstGeom>
           <a:solidFill>
-            <a:srgbClr val="DDDDDD"/>
+            <a:srgbClr val="D9D4CB"/>
           </a:solidFill>
           <a:ln/>
         </p:spPr>
@@ -3560,7 +3560,7 @@
             </a:avLst>
           </a:prstGeom>
           <a:solidFill>
-            <a:srgbClr val="FFFFFF"/>
+            <a:srgbClr val="FFFEF9"/>
           </a:solidFill>
           <a:ln/>
         </p:spPr>
@@ -3574,13 +3574,13 @@
         <p:spPr>
           <a:xfrm>
             <a:off x="548640" y="1005840"/>
-            <a:ext cx="73152" cy="685800"/>
-          </a:xfrm>
-          <a:prstGeom prst="rect">
-            <a:avLst/>
-          </a:prstGeom>
-          <a:solidFill>
-            <a:srgbClr val="003087"/>
+            <a:ext cx="91440" cy="685800"/>
+          </a:xfrm>
+          <a:prstGeom prst="rect">
+            <a:avLst/>
+          </a:prstGeom>
+          <a:solidFill>
+            <a:srgbClr val="2D5A27"/>
           </a:solidFill>
           <a:ln/>
         </p:spPr>
@@ -3593,14 +3593,14 @@
         </p:nvSpPr>
         <p:spPr>
           <a:xfrm>
-            <a:off x="685800" y="1165860"/>
-            <a:ext cx="365760" cy="365760"/>
+            <a:off x="667512" y="1147572"/>
+            <a:ext cx="402336" cy="402336"/>
           </a:xfrm>
           <a:prstGeom prst="ellipse">
             <a:avLst/>
           </a:prstGeom>
           <a:solidFill>
-            <a:srgbClr val="003087"/>
+            <a:srgbClr val="2D5A27"/>
           </a:solidFill>
           <a:ln/>
         </p:spPr>
@@ -3613,8 +3613,8 @@
         </p:nvSpPr>
         <p:spPr>
           <a:xfrm>
-            <a:off x="685800" y="1165860"/>
-            <a:ext cx="365760" cy="365760"/>
+            <a:off x="667512" y="1147572"/>
+            <a:ext cx="402336" cy="402336"/>
           </a:xfrm>
           <a:prstGeom prst="rect">
             <a:avLst/>
@@ -3630,9 +3630,9 @@
               <a:buNone/>
             </a:pPr>
             <a:r>
-              <a:rPr lang="en-US" sz="1100" b="1" dirty="0">
+              <a:rPr lang="en-US" sz="1200" b="1" dirty="0">
                 <a:solidFill>
-                  <a:srgbClr val="FFFFFF"/>
+                  <a:srgbClr val="FFFEF9"/>
                 </a:solidFill>
                 <a:latin typeface="Calibri" pitchFamily="34" charset="0"/>
                 <a:ea typeface="Calibri" pitchFamily="34" charset="-122"/>
@@ -3640,7 +3640,7 @@
               </a:rPr>
               <a:t>1</a:t>
             </a:r>
-            <a:endParaRPr lang="en-US" sz="1100" dirty="0"/>
+            <a:endParaRPr lang="en-US" sz="1200" dirty="0"/>
           </a:p>
         </p:txBody>
       </p:sp>
@@ -3671,7 +3671,7 @@
             <a:r>
               <a:rPr lang="en-US" sz="1400" dirty="0">
                 <a:solidFill>
-                  <a:srgbClr val="333333"/>
+                  <a:srgbClr val="3D3D3D"/>
                 </a:solidFill>
                 <a:latin typeface="Calibri" pitchFamily="34" charset="0"/>
                 <a:ea typeface="Calibri" pitchFamily="34" charset="-122"/>
@@ -3691,7 +3691,7 @@
         </p:nvSpPr>
         <p:spPr>
           <a:xfrm>
-            <a:off x="576072" y="1856232"/>
+            <a:off x="585216" y="1865376"/>
             <a:ext cx="8046720" cy="685800"/>
           </a:xfrm>
           <a:prstGeom prst="roundRect">
@@ -3700,7 +3700,7 @@
             </a:avLst>
           </a:prstGeom>
           <a:solidFill>
-            <a:srgbClr val="DDDDDD"/>
+            <a:srgbClr val="D9D4CB"/>
           </a:solidFill>
           <a:ln/>
         </p:spPr>
@@ -3722,7 +3722,7 @@
             </a:avLst>
           </a:prstGeom>
           <a:solidFill>
-            <a:srgbClr val="FFFFFF"/>
+            <a:srgbClr val="FFFEF9"/>
           </a:solidFill>
           <a:ln/>
         </p:spPr>
@@ -3736,13 +3736,13 @@
         <p:spPr>
           <a:xfrm>
             <a:off x="548640" y="1828800"/>
-            <a:ext cx="73152" cy="685800"/>
-          </a:xfrm>
-          <a:prstGeom prst="rect">
-            <a:avLst/>
-          </a:prstGeom>
-          <a:solidFill>
-            <a:srgbClr val="003087"/>
+            <a:ext cx="91440" cy="685800"/>
+          </a:xfrm>
+          <a:prstGeom prst="rect">
+            <a:avLst/>
+          </a:prstGeom>
+          <a:solidFill>
+            <a:srgbClr val="2D5A27"/>
           </a:solidFill>
           <a:ln/>
         </p:spPr>
@@ -3755,14 +3755,14 @@
         </p:nvSpPr>
         <p:spPr>
           <a:xfrm>
-            <a:off x="685800" y="1988820"/>
-            <a:ext cx="365760" cy="365760"/>
+            <a:off x="667512" y="1970532"/>
+            <a:ext cx="402336" cy="402336"/>
           </a:xfrm>
           <a:prstGeom prst="ellipse">
             <a:avLst/>
           </a:prstGeom>
           <a:solidFill>
-            <a:srgbClr val="003087"/>
+            <a:srgbClr val="2D5A27"/>
           </a:solidFill>
           <a:ln/>
         </p:spPr>
@@ -3775,8 +3775,8 @@
         </p:nvSpPr>
         <p:spPr>
           <a:xfrm>
-            <a:off x="685800" y="1988820"/>
-            <a:ext cx="365760" cy="365760"/>
+            <a:off x="667512" y="1970532"/>
+            <a:ext cx="402336" cy="402336"/>
           </a:xfrm>
           <a:prstGeom prst="rect">
             <a:avLst/>
@@ -3792,9 +3792,9 @@
               <a:buNone/>
             </a:pPr>
             <a:r>
-              <a:rPr lang="en-US" sz="1100" b="1" dirty="0">
+              <a:rPr lang="en-US" sz="1200" b="1" dirty="0">
                 <a:solidFill>
-                  <a:srgbClr val="FFFFFF"/>
+                  <a:srgbClr val="FFFEF9"/>
                 </a:solidFill>
                 <a:latin typeface="Calibri" pitchFamily="34" charset="0"/>
                 <a:ea typeface="Calibri" pitchFamily="34" charset="-122"/>
@@ -3802,7 +3802,7 @@
               </a:rPr>
               <a:t>2</a:t>
             </a:r>
-            <a:endParaRPr lang="en-US" sz="1100" dirty="0"/>
+            <a:endParaRPr lang="en-US" sz="1200" dirty="0"/>
           </a:p>
         </p:txBody>
       </p:sp>
@@ -3833,7 +3833,7 @@
             <a:r>
               <a:rPr lang="en-US" sz="1400" dirty="0">
                 <a:solidFill>
-                  <a:srgbClr val="333333"/>
+                  <a:srgbClr val="3D3D3D"/>
                 </a:solidFill>
                 <a:latin typeface="Calibri" pitchFamily="34" charset="0"/>
                 <a:ea typeface="Calibri" pitchFamily="34" charset="-122"/>
@@ -3853,7 +3853,7 @@
         </p:nvSpPr>
         <p:spPr>
           <a:xfrm>
-            <a:off x="576072" y="2679192"/>
+            <a:off x="585216" y="2688336"/>
             <a:ext cx="8046720" cy="685800"/>
           </a:xfrm>
           <a:prstGeom prst="roundRect">
@@ -3862,7 +3862,7 @@
             </a:avLst>
           </a:prstGeom>
           <a:solidFill>
-            <a:srgbClr val="DDDDDD"/>
+            <a:srgbClr val="D9D4CB"/>
           </a:solidFill>
           <a:ln/>
         </p:spPr>
@@ -3884,7 +3884,7 @@
             </a:avLst>
           </a:prstGeom>
           <a:solidFill>
-            <a:srgbClr val="FFFFFF"/>
+            <a:srgbClr val="FFFEF9"/>
           </a:solidFill>
           <a:ln/>
         </p:spPr>
@@ -3898,13 +3898,13 @@
         <p:spPr>
           <a:xfrm>
             <a:off x="548640" y="2651760"/>
-            <a:ext cx="73152" cy="685800"/>
-          </a:xfrm>
-          <a:prstGeom prst="rect">
-            <a:avLst/>
-          </a:prstGeom>
-          <a:solidFill>
-            <a:srgbClr val="003087"/>
+            <a:ext cx="91440" cy="685800"/>
+          </a:xfrm>
+          <a:prstGeom prst="rect">
+            <a:avLst/>
+          </a:prstGeom>
+          <a:solidFill>
+            <a:srgbClr val="2D5A27"/>
           </a:solidFill>
           <a:ln/>
         </p:spPr>
@@ -3917,14 +3917,14 @@
         </p:nvSpPr>
         <p:spPr>
           <a:xfrm>
-            <a:off x="685800" y="2811780"/>
-            <a:ext cx="365760" cy="365760"/>
+            <a:off x="667512" y="2793492"/>
+            <a:ext cx="402336" cy="402336"/>
           </a:xfrm>
           <a:prstGeom prst="ellipse">
             <a:avLst/>
           </a:prstGeom>
           <a:solidFill>
-            <a:srgbClr val="003087"/>
+            <a:srgbClr val="2D5A27"/>
           </a:solidFill>
           <a:ln/>
         </p:spPr>
@@ -3937,8 +3937,8 @@
         </p:nvSpPr>
         <p:spPr>
           <a:xfrm>
-            <a:off x="685800" y="2811780"/>
-            <a:ext cx="365760" cy="365760"/>
+            <a:off x="667512" y="2793492"/>
+            <a:ext cx="402336" cy="402336"/>
           </a:xfrm>
           <a:prstGeom prst="rect">
             <a:avLst/>
@@ -3954,9 +3954,9 @@
               <a:buNone/>
             </a:pPr>
             <a:r>
-              <a:rPr lang="en-US" sz="1100" b="1" dirty="0">
+              <a:rPr lang="en-US" sz="1200" b="1" dirty="0">
                 <a:solidFill>
-                  <a:srgbClr val="FFFFFF"/>
+                  <a:srgbClr val="FFFEF9"/>
                 </a:solidFill>
                 <a:latin typeface="Calibri" pitchFamily="34" charset="0"/>
                 <a:ea typeface="Calibri" pitchFamily="34" charset="-122"/>
@@ -3964,7 +3964,7 @@
               </a:rPr>
               <a:t>3</a:t>
             </a:r>
-            <a:endParaRPr lang="en-US" sz="1100" dirty="0"/>
+            <a:endParaRPr lang="en-US" sz="1200" dirty="0"/>
           </a:p>
         </p:txBody>
       </p:sp>
@@ -3995,7 +3995,7 @@
             <a:r>
               <a:rPr lang="en-US" sz="1400" dirty="0">
                 <a:solidFill>
-                  <a:srgbClr val="333333"/>
+                  <a:srgbClr val="3D3D3D"/>
                 </a:solidFill>
                 <a:latin typeface="Calibri" pitchFamily="34" charset="0"/>
                 <a:ea typeface="Calibri" pitchFamily="34" charset="-122"/>
@@ -4015,7 +4015,7 @@
         </p:nvSpPr>
         <p:spPr>
           <a:xfrm>
-            <a:off x="576072" y="3502152"/>
+            <a:off x="585216" y="3511296"/>
             <a:ext cx="8046720" cy="685800"/>
           </a:xfrm>
           <a:prstGeom prst="roundRect">
@@ -4024,7 +4024,7 @@
             </a:avLst>
           </a:prstGeom>
           <a:solidFill>
-            <a:srgbClr val="DDDDDD"/>
+            <a:srgbClr val="D9D4CB"/>
           </a:solidFill>
           <a:ln/>
         </p:spPr>
@@ -4046,7 +4046,7 @@
             </a:avLst>
           </a:prstGeom>
           <a:solidFill>
-            <a:srgbClr val="FFFFFF"/>
+            <a:srgbClr val="FFFEF9"/>
           </a:solidFill>
           <a:ln/>
         </p:spPr>
@@ -4060,13 +4060,13 @@
         <p:spPr>
           <a:xfrm>
             <a:off x="548640" y="3474720"/>
-            <a:ext cx="73152" cy="685800"/>
-          </a:xfrm>
-          <a:prstGeom prst="rect">
-            <a:avLst/>
-          </a:prstGeom>
-          <a:solidFill>
-            <a:srgbClr val="003087"/>
+            <a:ext cx="91440" cy="685800"/>
+          </a:xfrm>
+          <a:prstGeom prst="rect">
+            <a:avLst/>
+          </a:prstGeom>
+          <a:solidFill>
+            <a:srgbClr val="2D5A27"/>
           </a:solidFill>
           <a:ln/>
         </p:spPr>
@@ -4079,14 +4079,14 @@
         </p:nvSpPr>
         <p:spPr>
           <a:xfrm>
-            <a:off x="685800" y="3634740"/>
-            <a:ext cx="365760" cy="365760"/>
+            <a:off x="667512" y="3616452"/>
+            <a:ext cx="402336" cy="402336"/>
           </a:xfrm>
           <a:prstGeom prst="ellipse">
             <a:avLst/>
           </a:prstGeom>
           <a:solidFill>
-            <a:srgbClr val="003087"/>
+            <a:srgbClr val="2D5A27"/>
           </a:solidFill>
           <a:ln/>
         </p:spPr>
@@ -4099,8 +4099,8 @@
         </p:nvSpPr>
         <p:spPr>
           <a:xfrm>
-            <a:off x="685800" y="3634740"/>
-            <a:ext cx="365760" cy="365760"/>
+            <a:off x="667512" y="3616452"/>
+            <a:ext cx="402336" cy="402336"/>
           </a:xfrm>
           <a:prstGeom prst="rect">
             <a:avLst/>
@@ -4116,9 +4116,9 @@
               <a:buNone/>
             </a:pPr>
             <a:r>
-              <a:rPr lang="en-US" sz="1100" b="1" dirty="0">
+              <a:rPr lang="en-US" sz="1200" b="1" dirty="0">
                 <a:solidFill>
-                  <a:srgbClr val="FFFFFF"/>
+                  <a:srgbClr val="FFFEF9"/>
                 </a:solidFill>
                 <a:latin typeface="Calibri" pitchFamily="34" charset="0"/>
                 <a:ea typeface="Calibri" pitchFamily="34" charset="-122"/>
@@ -4126,7 +4126,7 @@
               </a:rPr>
               <a:t>4</a:t>
             </a:r>
-            <a:endParaRPr lang="en-US" sz="1100" dirty="0"/>
+            <a:endParaRPr lang="en-US" sz="1200" dirty="0"/>
           </a:p>
         </p:txBody>
       </p:sp>
@@ -4157,7 +4157,7 @@
             <a:r>
               <a:rPr lang="en-US" sz="1400" dirty="0">
                 <a:solidFill>
-                  <a:srgbClr val="333333"/>
+                  <a:srgbClr val="3D3D3D"/>
                 </a:solidFill>
                 <a:latin typeface="Calibri" pitchFamily="34" charset="0"/>
                 <a:ea typeface="Calibri" pitchFamily="34" charset="-122"/>
@@ -4186,7 +4186,7 @@
             </a:avLst>
           </a:prstGeom>
           <a:solidFill>
-            <a:srgbClr val="003087"/>
+            <a:srgbClr val="2D5A27"/>
           </a:solidFill>
           <a:ln/>
         </p:spPr>
@@ -4218,7 +4218,7 @@
             <a:r>
               <a:rPr lang="en-US" sz="1300" i="1" dirty="0">
                 <a:solidFill>
-                  <a:srgbClr val="FFFFFF"/>
+                  <a:srgbClr val="FFFEF9"/>
                 </a:solidFill>
                 <a:latin typeface="Calibri" pitchFamily="34" charset="0"/>
                 <a:ea typeface="Calibri" pitchFamily="34" charset="-122"/>
@@ -4247,7 +4247,7 @@
             </a:avLst>
           </a:prstGeom>
           <a:solidFill>
-            <a:srgbClr val="003087"/>
+            <a:srgbClr val="2D5A27"/>
           </a:solidFill>
           <a:ln/>
         </p:spPr>
@@ -4279,7 +4279,7 @@
             <a:r>
               <a:rPr lang="en-US" sz="1300" i="1" dirty="0">
                 <a:solidFill>
-                  <a:srgbClr val="FFFFFF"/>
+                  <a:srgbClr val="FFFEF9"/>
                 </a:solidFill>
                 <a:latin typeface="Calibri" pitchFamily="34" charset="0"/>
                 <a:ea typeface="Calibri" pitchFamily="34" charset="-122"/>
@@ -4329,7 +4329,7 @@
     <p:bg>
       <p:bgPr>
         <a:solidFill>
-          <a:srgbClr val="F5F5F5"/>
+          <a:srgbClr val="FDF8F3"/>
         </a:solidFill>
       </p:bgPr>
     </p:bg>
@@ -4374,7 +4374,7 @@
             <a:r>
               <a:rPr lang="en-US" sz="2600" b="1" dirty="0">
                 <a:solidFill>
-                  <a:srgbClr val="003087"/>
+                  <a:srgbClr val="2D5A27"/>
                 </a:solidFill>
                 <a:latin typeface="Georgia" pitchFamily="34" charset="0"/>
                 <a:ea typeface="Georgia" pitchFamily="34" charset="-122"/>
@@ -4401,7 +4401,7 @@
             <a:avLst/>
           </a:prstGeom>
           <a:solidFill>
-            <a:srgbClr val="E67E22"/>
+            <a:srgbClr val="D4A574"/>
           </a:solidFill>
           <a:ln/>
         </p:spPr>
@@ -4414,7 +4414,7 @@
         </p:nvSpPr>
         <p:spPr>
           <a:xfrm>
-            <a:off x="576072" y="1033272"/>
+            <a:off x="585216" y="1042416"/>
             <a:ext cx="8046720" cy="685800"/>
           </a:xfrm>
           <a:prstGeom prst="roundRect">
@@ -4423,7 +4423,7 @@
             </a:avLst>
           </a:prstGeom>
           <a:solidFill>
-            <a:srgbClr val="DDDDDD"/>
+            <a:srgbClr val="D9D4CB"/>
           </a:solidFill>
           <a:ln/>
         </p:spPr>
@@ -4445,7 +4445,7 @@
             </a:avLst>
           </a:prstGeom>
           <a:solidFill>
-            <a:srgbClr val="FFFFFF"/>
+            <a:srgbClr val="FFFEF9"/>
           </a:solidFill>
           <a:ln/>
         </p:spPr>
@@ -4459,13 +4459,13 @@
         <p:spPr>
           <a:xfrm>
             <a:off x="548640" y="1005840"/>
-            <a:ext cx="73152" cy="685800"/>
-          </a:xfrm>
-          <a:prstGeom prst="rect">
-            <a:avLst/>
-          </a:prstGeom>
-          <a:solidFill>
-            <a:srgbClr val="003087"/>
+            <a:ext cx="91440" cy="685800"/>
+          </a:xfrm>
+          <a:prstGeom prst="rect">
+            <a:avLst/>
+          </a:prstGeom>
+          <a:solidFill>
+            <a:srgbClr val="2D5A27"/>
           </a:solidFill>
           <a:ln/>
         </p:spPr>
@@ -4478,14 +4478,14 @@
         </p:nvSpPr>
         <p:spPr>
           <a:xfrm>
-            <a:off x="685800" y="1165860"/>
-            <a:ext cx="365760" cy="365760"/>
+            <a:off x="667512" y="1147572"/>
+            <a:ext cx="402336" cy="402336"/>
           </a:xfrm>
           <a:prstGeom prst="ellipse">
             <a:avLst/>
           </a:prstGeom>
           <a:solidFill>
-            <a:srgbClr val="003087"/>
+            <a:srgbClr val="2D5A27"/>
           </a:solidFill>
           <a:ln/>
         </p:spPr>
@@ -4498,8 +4498,8 @@
         </p:nvSpPr>
         <p:spPr>
           <a:xfrm>
-            <a:off x="685800" y="1165860"/>
-            <a:ext cx="365760" cy="365760"/>
+            <a:off x="667512" y="1147572"/>
+            <a:ext cx="402336" cy="402336"/>
           </a:xfrm>
           <a:prstGeom prst="rect">
             <a:avLst/>
@@ -4515,9 +4515,9 @@
               <a:buNone/>
             </a:pPr>
             <a:r>
-              <a:rPr lang="en-US" sz="1100" b="1" dirty="0">
+              <a:rPr lang="en-US" sz="1200" b="1" dirty="0">
                 <a:solidFill>
-                  <a:srgbClr val="FFFFFF"/>
+                  <a:srgbClr val="FFFEF9"/>
                 </a:solidFill>
                 <a:latin typeface="Calibri" pitchFamily="34" charset="0"/>
                 <a:ea typeface="Calibri" pitchFamily="34" charset="-122"/>
@@ -4525,7 +4525,7 @@
               </a:rPr>
               <a:t>1</a:t>
             </a:r>
-            <a:endParaRPr lang="en-US" sz="1100" dirty="0"/>
+            <a:endParaRPr lang="en-US" sz="1200" dirty="0"/>
           </a:p>
         </p:txBody>
       </p:sp>
@@ -4556,7 +4556,7 @@
             <a:r>
               <a:rPr lang="en-US" sz="1400" dirty="0">
                 <a:solidFill>
-                  <a:srgbClr val="333333"/>
+                  <a:srgbClr val="3D3D3D"/>
                 </a:solidFill>
                 <a:latin typeface="Calibri" pitchFamily="34" charset="0"/>
                 <a:ea typeface="Calibri" pitchFamily="34" charset="-122"/>
@@ -4576,7 +4576,7 @@
         </p:nvSpPr>
         <p:spPr>
           <a:xfrm>
-            <a:off x="576072" y="1856232"/>
+            <a:off x="585216" y="1865376"/>
             <a:ext cx="8046720" cy="685800"/>
           </a:xfrm>
           <a:prstGeom prst="roundRect">
@@ -4585,7 +4585,7 @@
             </a:avLst>
           </a:prstGeom>
           <a:solidFill>
-            <a:srgbClr val="DDDDDD"/>
+            <a:srgbClr val="D9D4CB"/>
           </a:solidFill>
           <a:ln/>
         </p:spPr>
@@ -4607,7 +4607,7 @@
             </a:avLst>
           </a:prstGeom>
           <a:solidFill>
-            <a:srgbClr val="FFFFFF"/>
+            <a:srgbClr val="FFFEF9"/>
           </a:solidFill>
           <a:ln/>
         </p:spPr>
@@ -4621,13 +4621,13 @@
         <p:spPr>
           <a:xfrm>
             <a:off x="548640" y="1828800"/>
-            <a:ext cx="73152" cy="685800"/>
-          </a:xfrm>
-          <a:prstGeom prst="rect">
-            <a:avLst/>
-          </a:prstGeom>
-          <a:solidFill>
-            <a:srgbClr val="003087"/>
+            <a:ext cx="91440" cy="685800"/>
+          </a:xfrm>
+          <a:prstGeom prst="rect">
+            <a:avLst/>
+          </a:prstGeom>
+          <a:solidFill>
+            <a:srgbClr val="2D5A27"/>
           </a:solidFill>
           <a:ln/>
         </p:spPr>
@@ -4640,14 +4640,14 @@
         </p:nvSpPr>
         <p:spPr>
           <a:xfrm>
-            <a:off x="685800" y="1988820"/>
-            <a:ext cx="365760" cy="365760"/>
+            <a:off x="667512" y="1970532"/>
+            <a:ext cx="402336" cy="402336"/>
           </a:xfrm>
           <a:prstGeom prst="ellipse">
             <a:avLst/>
           </a:prstGeom>
           <a:solidFill>
-            <a:srgbClr val="003087"/>
+            <a:srgbClr val="2D5A27"/>
           </a:solidFill>
           <a:ln/>
         </p:spPr>
@@ -4660,8 +4660,8 @@
         </p:nvSpPr>
         <p:spPr>
           <a:xfrm>
-            <a:off x="685800" y="1988820"/>
-            <a:ext cx="365760" cy="365760"/>
+            <a:off x="667512" y="1970532"/>
+            <a:ext cx="402336" cy="402336"/>
           </a:xfrm>
           <a:prstGeom prst="rect">
             <a:avLst/>
@@ -4677,9 +4677,9 @@
               <a:buNone/>
             </a:pPr>
             <a:r>
-              <a:rPr lang="en-US" sz="1100" b="1" dirty="0">
+              <a:rPr lang="en-US" sz="1200" b="1" dirty="0">
                 <a:solidFill>
-                  <a:srgbClr val="FFFFFF"/>
+                  <a:srgbClr val="FFFEF9"/>
                 </a:solidFill>
                 <a:latin typeface="Calibri" pitchFamily="34" charset="0"/>
                 <a:ea typeface="Calibri" pitchFamily="34" charset="-122"/>
@@ -4687,7 +4687,7 @@
               </a:rPr>
               <a:t>2</a:t>
             </a:r>
-            <a:endParaRPr lang="en-US" sz="1100" dirty="0"/>
+            <a:endParaRPr lang="en-US" sz="1200" dirty="0"/>
           </a:p>
         </p:txBody>
       </p:sp>
@@ -4718,7 +4718,7 @@
             <a:r>
               <a:rPr lang="en-US" sz="1400" dirty="0">
                 <a:solidFill>
-                  <a:srgbClr val="333333"/>
+                  <a:srgbClr val="3D3D3D"/>
                 </a:solidFill>
                 <a:latin typeface="Calibri" pitchFamily="34" charset="0"/>
                 <a:ea typeface="Calibri" pitchFamily="34" charset="-122"/>
@@ -4738,7 +4738,7 @@
         </p:nvSpPr>
         <p:spPr>
           <a:xfrm>
-            <a:off x="576072" y="2679192"/>
+            <a:off x="585216" y="2688336"/>
             <a:ext cx="8046720" cy="685800"/>
           </a:xfrm>
           <a:prstGeom prst="roundRect">
@@ -4747,7 +4747,7 @@
             </a:avLst>
           </a:prstGeom>
           <a:solidFill>
-            <a:srgbClr val="DDDDDD"/>
+            <a:srgbClr val="D9D4CB"/>
           </a:solidFill>
           <a:ln/>
         </p:spPr>
@@ -4769,7 +4769,7 @@
             </a:avLst>
           </a:prstGeom>
           <a:solidFill>
-            <a:srgbClr val="FFFFFF"/>
+            <a:srgbClr val="FFFEF9"/>
           </a:solidFill>
           <a:ln/>
         </p:spPr>
@@ -4783,13 +4783,13 @@
         <p:spPr>
           <a:xfrm>
             <a:off x="548640" y="2651760"/>
-            <a:ext cx="73152" cy="685800"/>
-          </a:xfrm>
-          <a:prstGeom prst="rect">
-            <a:avLst/>
-          </a:prstGeom>
-          <a:solidFill>
-            <a:srgbClr val="003087"/>
+            <a:ext cx="91440" cy="685800"/>
+          </a:xfrm>
+          <a:prstGeom prst="rect">
+            <a:avLst/>
+          </a:prstGeom>
+          <a:solidFill>
+            <a:srgbClr val="2D5A27"/>
           </a:solidFill>
           <a:ln/>
         </p:spPr>
@@ -4802,14 +4802,14 @@
         </p:nvSpPr>
         <p:spPr>
           <a:xfrm>
-            <a:off x="685800" y="2811780"/>
-            <a:ext cx="365760" cy="365760"/>
+            <a:off x="667512" y="2793492"/>
+            <a:ext cx="402336" cy="402336"/>
           </a:xfrm>
           <a:prstGeom prst="ellipse">
             <a:avLst/>
           </a:prstGeom>
           <a:solidFill>
-            <a:srgbClr val="003087"/>
+            <a:srgbClr val="2D5A27"/>
           </a:solidFill>
           <a:ln/>
         </p:spPr>
@@ -4822,8 +4822,8 @@
         </p:nvSpPr>
         <p:spPr>
           <a:xfrm>
-            <a:off x="685800" y="2811780"/>
-            <a:ext cx="365760" cy="365760"/>
+            <a:off x="667512" y="2793492"/>
+            <a:ext cx="402336" cy="402336"/>
           </a:xfrm>
           <a:prstGeom prst="rect">
             <a:avLst/>
@@ -4839,9 +4839,9 @@
               <a:buNone/>
             </a:pPr>
             <a:r>
-              <a:rPr lang="en-US" sz="1100" b="1" dirty="0">
+              <a:rPr lang="en-US" sz="1200" b="1" dirty="0">
                 <a:solidFill>
-                  <a:srgbClr val="FFFFFF"/>
+                  <a:srgbClr val="FFFEF9"/>
                 </a:solidFill>
                 <a:latin typeface="Calibri" pitchFamily="34" charset="0"/>
                 <a:ea typeface="Calibri" pitchFamily="34" charset="-122"/>
@@ -4849,7 +4849,7 @@
               </a:rPr>
               <a:t>3</a:t>
             </a:r>
-            <a:endParaRPr lang="en-US" sz="1100" dirty="0"/>
+            <a:endParaRPr lang="en-US" sz="1200" dirty="0"/>
           </a:p>
         </p:txBody>
       </p:sp>
@@ -4880,7 +4880,7 @@
             <a:r>
               <a:rPr lang="en-US" sz="1400" dirty="0">
                 <a:solidFill>
-                  <a:srgbClr val="333333"/>
+                  <a:srgbClr val="3D3D3D"/>
                 </a:solidFill>
                 <a:latin typeface="Calibri" pitchFamily="34" charset="0"/>
                 <a:ea typeface="Calibri" pitchFamily="34" charset="-122"/>
@@ -4900,7 +4900,7 @@
         </p:nvSpPr>
         <p:spPr>
           <a:xfrm>
-            <a:off x="576072" y="3502152"/>
+            <a:off x="585216" y="3511296"/>
             <a:ext cx="8046720" cy="685800"/>
           </a:xfrm>
           <a:prstGeom prst="roundRect">
@@ -4909,7 +4909,7 @@
             </a:avLst>
           </a:prstGeom>
           <a:solidFill>
-            <a:srgbClr val="DDDDDD"/>
+            <a:srgbClr val="D9D4CB"/>
           </a:solidFill>
           <a:ln/>
         </p:spPr>
@@ -4931,7 +4931,7 @@
             </a:avLst>
           </a:prstGeom>
           <a:solidFill>
-            <a:srgbClr val="FFFFFF"/>
+            <a:srgbClr val="FFFEF9"/>
           </a:solidFill>
           <a:ln/>
         </p:spPr>
@@ -4945,13 +4945,13 @@
         <p:spPr>
           <a:xfrm>
             <a:off x="548640" y="3474720"/>
-            <a:ext cx="73152" cy="685800"/>
-          </a:xfrm>
-          <a:prstGeom prst="rect">
-            <a:avLst/>
-          </a:prstGeom>
-          <a:solidFill>
-            <a:srgbClr val="003087"/>
+            <a:ext cx="91440" cy="685800"/>
+          </a:xfrm>
+          <a:prstGeom prst="rect">
+            <a:avLst/>
+          </a:prstGeom>
+          <a:solidFill>
+            <a:srgbClr val="2D5A27"/>
           </a:solidFill>
           <a:ln/>
         </p:spPr>
@@ -4964,14 +4964,14 @@
         </p:nvSpPr>
         <p:spPr>
           <a:xfrm>
-            <a:off x="685800" y="3634740"/>
-            <a:ext cx="365760" cy="365760"/>
+            <a:off x="667512" y="3616452"/>
+            <a:ext cx="402336" cy="402336"/>
           </a:xfrm>
           <a:prstGeom prst="ellipse">
             <a:avLst/>
           </a:prstGeom>
           <a:solidFill>
-            <a:srgbClr val="003087"/>
+            <a:srgbClr val="2D5A27"/>
           </a:solidFill>
           <a:ln/>
         </p:spPr>
@@ -4984,8 +4984,8 @@
         </p:nvSpPr>
         <p:spPr>
           <a:xfrm>
-            <a:off x="685800" y="3634740"/>
-            <a:ext cx="365760" cy="365760"/>
+            <a:off x="667512" y="3616452"/>
+            <a:ext cx="402336" cy="402336"/>
           </a:xfrm>
           <a:prstGeom prst="rect">
             <a:avLst/>
@@ -5001,9 +5001,9 @@
               <a:buNone/>
             </a:pPr>
             <a:r>
-              <a:rPr lang="en-US" sz="1100" b="1" dirty="0">
+              <a:rPr lang="en-US" sz="1200" b="1" dirty="0">
                 <a:solidFill>
-                  <a:srgbClr val="FFFFFF"/>
+                  <a:srgbClr val="FFFEF9"/>
                 </a:solidFill>
                 <a:latin typeface="Calibri" pitchFamily="34" charset="0"/>
                 <a:ea typeface="Calibri" pitchFamily="34" charset="-122"/>
@@ -5011,7 +5011,7 @@
               </a:rPr>
               <a:t>4</a:t>
             </a:r>
-            <a:endParaRPr lang="en-US" sz="1100" dirty="0"/>
+            <a:endParaRPr lang="en-US" sz="1200" dirty="0"/>
           </a:p>
         </p:txBody>
       </p:sp>
@@ -5042,7 +5042,7 @@
             <a:r>
               <a:rPr lang="en-US" sz="1400" dirty="0">
                 <a:solidFill>
-                  <a:srgbClr val="333333"/>
+                  <a:srgbClr val="3D3D3D"/>
                 </a:solidFill>
                 <a:latin typeface="Calibri" pitchFamily="34" charset="0"/>
                 <a:ea typeface="Calibri" pitchFamily="34" charset="-122"/>
@@ -5071,7 +5071,7 @@
             </a:avLst>
           </a:prstGeom>
           <a:solidFill>
-            <a:srgbClr val="003087"/>
+            <a:srgbClr val="2D5A27"/>
           </a:solidFill>
           <a:ln/>
         </p:spPr>
@@ -5103,7 +5103,7 @@
             <a:r>
               <a:rPr lang="en-US" sz="1300" i="1" dirty="0">
                 <a:solidFill>
-                  <a:srgbClr val="FFFFFF"/>
+                  <a:srgbClr val="FFFEF9"/>
                 </a:solidFill>
                 <a:latin typeface="Calibri" pitchFamily="34" charset="0"/>
                 <a:ea typeface="Calibri" pitchFamily="34" charset="-122"/>
@@ -5132,7 +5132,7 @@
             </a:avLst>
           </a:prstGeom>
           <a:solidFill>
-            <a:srgbClr val="003087"/>
+            <a:srgbClr val="2D5A27"/>
           </a:solidFill>
           <a:ln/>
         </p:spPr>
@@ -5164,7 +5164,7 @@
             <a:r>
               <a:rPr lang="en-US" sz="1300" i="1" dirty="0">
                 <a:solidFill>
-                  <a:srgbClr val="FFFFFF"/>
+                  <a:srgbClr val="FFFEF9"/>
                 </a:solidFill>
                 <a:latin typeface="Calibri" pitchFamily="34" charset="0"/>
                 <a:ea typeface="Calibri" pitchFamily="34" charset="-122"/>
@@ -5190,7 +5190,7 @@
     <p:bg>
       <p:bgPr>
         <a:solidFill>
-          <a:srgbClr val="F5F5F5"/>
+          <a:srgbClr val="FDF8F3"/>
         </a:solidFill>
       </p:bgPr>
     </p:bg>
@@ -5235,7 +5235,7 @@
             <a:r>
               <a:rPr lang="en-US" sz="2600" b="1" dirty="0">
                 <a:solidFill>
-                  <a:srgbClr val="003087"/>
+                  <a:srgbClr val="2D5A27"/>
                 </a:solidFill>
                 <a:latin typeface="Georgia" pitchFamily="34" charset="0"/>
                 <a:ea typeface="Georgia" pitchFamily="34" charset="-122"/>
@@ -5262,7 +5262,7 @@
             <a:avLst/>
           </a:prstGeom>
           <a:solidFill>
-            <a:srgbClr val="E67E22"/>
+            <a:srgbClr val="D4A574"/>
           </a:solidFill>
           <a:ln/>
         </p:spPr>
@@ -5281,7 +5281,7 @@
     <p:bg>
       <p:bgPr>
         <a:solidFill>
-          <a:srgbClr val="F5F5F5"/>
+          <a:srgbClr val="FDF8F3"/>
         </a:solidFill>
       </p:bgPr>
     </p:bg>
@@ -5326,7 +5326,7 @@
             <a:r>
               <a:rPr lang="en-US" sz="2600" b="1" dirty="0">
                 <a:solidFill>
-                  <a:srgbClr val="003087"/>
+                  <a:srgbClr val="2D5A27"/>
                 </a:solidFill>
                 <a:latin typeface="Georgia" pitchFamily="34" charset="0"/>
                 <a:ea typeface="Georgia" pitchFamily="34" charset="-122"/>
@@ -5353,7 +5353,7 @@
             <a:avLst/>
           </a:prstGeom>
           <a:solidFill>
-            <a:srgbClr val="E67E22"/>
+            <a:srgbClr val="D4A574"/>
           </a:solidFill>
           <a:ln/>
         </p:spPr>
@@ -5366,7 +5366,7 @@
         </p:nvSpPr>
         <p:spPr>
           <a:xfrm>
-            <a:off x="576072" y="1033272"/>
+            <a:off x="585216" y="1042416"/>
             <a:ext cx="8046720" cy="685800"/>
           </a:xfrm>
           <a:prstGeom prst="roundRect">
@@ -5375,7 +5375,7 @@
             </a:avLst>
           </a:prstGeom>
           <a:solidFill>
-            <a:srgbClr val="DDDDDD"/>
+            <a:srgbClr val="D9D4CB"/>
           </a:solidFill>
           <a:ln/>
         </p:spPr>
@@ -5397,7 +5397,7 @@
             </a:avLst>
           </a:prstGeom>
           <a:solidFill>
-            <a:srgbClr val="FFFFFF"/>
+            <a:srgbClr val="FFFEF9"/>
           </a:solidFill>
           <a:ln/>
         </p:spPr>
@@ -5411,13 +5411,13 @@
         <p:spPr>
           <a:xfrm>
             <a:off x="548640" y="1005840"/>
-            <a:ext cx="73152" cy="685800"/>
-          </a:xfrm>
-          <a:prstGeom prst="rect">
-            <a:avLst/>
-          </a:prstGeom>
-          <a:solidFill>
-            <a:srgbClr val="003087"/>
+            <a:ext cx="91440" cy="685800"/>
+          </a:xfrm>
+          <a:prstGeom prst="rect">
+            <a:avLst/>
+          </a:prstGeom>
+          <a:solidFill>
+            <a:srgbClr val="2D5A27"/>
           </a:solidFill>
           <a:ln/>
         </p:spPr>
@@ -5430,14 +5430,14 @@
         </p:nvSpPr>
         <p:spPr>
           <a:xfrm>
-            <a:off x="685800" y="1165860"/>
-            <a:ext cx="365760" cy="365760"/>
+            <a:off x="667512" y="1147572"/>
+            <a:ext cx="402336" cy="402336"/>
           </a:xfrm>
           <a:prstGeom prst="ellipse">
             <a:avLst/>
           </a:prstGeom>
           <a:solidFill>
-            <a:srgbClr val="003087"/>
+            <a:srgbClr val="2D5A27"/>
           </a:solidFill>
           <a:ln/>
         </p:spPr>
@@ -5450,8 +5450,8 @@
         </p:nvSpPr>
         <p:spPr>
           <a:xfrm>
-            <a:off x="685800" y="1165860"/>
-            <a:ext cx="365760" cy="365760"/>
+            <a:off x="667512" y="1147572"/>
+            <a:ext cx="402336" cy="402336"/>
           </a:xfrm>
           <a:prstGeom prst="rect">
             <a:avLst/>
@@ -5467,9 +5467,9 @@
               <a:buNone/>
             </a:pPr>
             <a:r>
-              <a:rPr lang="en-US" sz="1100" b="1" dirty="0">
+              <a:rPr lang="en-US" sz="1200" b="1" dirty="0">
                 <a:solidFill>
-                  <a:srgbClr val="FFFFFF"/>
+                  <a:srgbClr val="FFFEF9"/>
                 </a:solidFill>
                 <a:latin typeface="Calibri" pitchFamily="34" charset="0"/>
                 <a:ea typeface="Calibri" pitchFamily="34" charset="-122"/>
@@ -5477,7 +5477,7 @@
               </a:rPr>
               <a:t>1</a:t>
             </a:r>
-            <a:endParaRPr lang="en-US" sz="1100" dirty="0"/>
+            <a:endParaRPr lang="en-US" sz="1200" dirty="0"/>
           </a:p>
         </p:txBody>
       </p:sp>
@@ -5508,7 +5508,7 @@
             <a:r>
               <a:rPr lang="en-US" sz="1400" dirty="0">
                 <a:solidFill>
-                  <a:srgbClr val="333333"/>
+                  <a:srgbClr val="3D3D3D"/>
                 </a:solidFill>
                 <a:latin typeface="Calibri" pitchFamily="34" charset="0"/>
                 <a:ea typeface="Calibri" pitchFamily="34" charset="-122"/>
@@ -5528,7 +5528,7 @@
         </p:nvSpPr>
         <p:spPr>
           <a:xfrm>
-            <a:off x="576072" y="1856232"/>
+            <a:off x="585216" y="1865376"/>
             <a:ext cx="8046720" cy="685800"/>
           </a:xfrm>
           <a:prstGeom prst="roundRect">
@@ -5537,7 +5537,7 @@
             </a:avLst>
           </a:prstGeom>
           <a:solidFill>
-            <a:srgbClr val="DDDDDD"/>
+            <a:srgbClr val="D9D4CB"/>
           </a:solidFill>
           <a:ln/>
         </p:spPr>
@@ -5559,7 +5559,7 @@
             </a:avLst>
           </a:prstGeom>
           <a:solidFill>
-            <a:srgbClr val="FFFFFF"/>
+            <a:srgbClr val="FFFEF9"/>
           </a:solidFill>
           <a:ln/>
         </p:spPr>
@@ -5573,13 +5573,13 @@
         <p:spPr>
           <a:xfrm>
             <a:off x="548640" y="1828800"/>
-            <a:ext cx="73152" cy="685800"/>
-          </a:xfrm>
-          <a:prstGeom prst="rect">
-            <a:avLst/>
-          </a:prstGeom>
-          <a:solidFill>
-            <a:srgbClr val="003087"/>
+            <a:ext cx="91440" cy="685800"/>
+          </a:xfrm>
+          <a:prstGeom prst="rect">
+            <a:avLst/>
+          </a:prstGeom>
+          <a:solidFill>
+            <a:srgbClr val="2D5A27"/>
           </a:solidFill>
           <a:ln/>
         </p:spPr>
@@ -5592,14 +5592,14 @@
         </p:nvSpPr>
         <p:spPr>
           <a:xfrm>
-            <a:off x="685800" y="1988820"/>
-            <a:ext cx="365760" cy="365760"/>
+            <a:off x="667512" y="1970532"/>
+            <a:ext cx="402336" cy="402336"/>
           </a:xfrm>
           <a:prstGeom prst="ellipse">
             <a:avLst/>
           </a:prstGeom>
           <a:solidFill>
-            <a:srgbClr val="003087"/>
+            <a:srgbClr val="2D5A27"/>
           </a:solidFill>
           <a:ln/>
         </p:spPr>
@@ -5612,8 +5612,8 @@
         </p:nvSpPr>
         <p:spPr>
           <a:xfrm>
-            <a:off x="685800" y="1988820"/>
-            <a:ext cx="365760" cy="365760"/>
+            <a:off x="667512" y="1970532"/>
+            <a:ext cx="402336" cy="402336"/>
           </a:xfrm>
           <a:prstGeom prst="rect">
             <a:avLst/>
@@ -5629,9 +5629,9 @@
               <a:buNone/>
             </a:pPr>
             <a:r>
-              <a:rPr lang="en-US" sz="1100" b="1" dirty="0">
+              <a:rPr lang="en-US" sz="1200" b="1" dirty="0">
                 <a:solidFill>
-                  <a:srgbClr val="FFFFFF"/>
+                  <a:srgbClr val="FFFEF9"/>
                 </a:solidFill>
                 <a:latin typeface="Calibri" pitchFamily="34" charset="0"/>
                 <a:ea typeface="Calibri" pitchFamily="34" charset="-122"/>
@@ -5639,7 +5639,7 @@
               </a:rPr>
               <a:t>2</a:t>
             </a:r>
-            <a:endParaRPr lang="en-US" sz="1100" dirty="0"/>
+            <a:endParaRPr lang="en-US" sz="1200" dirty="0"/>
           </a:p>
         </p:txBody>
       </p:sp>
@@ -5670,7 +5670,7 @@
             <a:r>
               <a:rPr lang="en-US" sz="1400" dirty="0">
                 <a:solidFill>
-                  <a:srgbClr val="333333"/>
+                  <a:srgbClr val="3D3D3D"/>
                 </a:solidFill>
                 <a:latin typeface="Calibri" pitchFamily="34" charset="0"/>
                 <a:ea typeface="Calibri" pitchFamily="34" charset="-122"/>
@@ -5690,7 +5690,7 @@
         </p:nvSpPr>
         <p:spPr>
           <a:xfrm>
-            <a:off x="576072" y="2679192"/>
+            <a:off x="585216" y="2688336"/>
             <a:ext cx="8046720" cy="685800"/>
           </a:xfrm>
           <a:prstGeom prst="roundRect">
@@ -5699,7 +5699,7 @@
             </a:avLst>
           </a:prstGeom>
           <a:solidFill>
-            <a:srgbClr val="DDDDDD"/>
+            <a:srgbClr val="D9D4CB"/>
           </a:solidFill>
           <a:ln/>
         </p:spPr>
@@ -5721,7 +5721,7 @@
             </a:avLst>
           </a:prstGeom>
           <a:solidFill>
-            <a:srgbClr val="FFFFFF"/>
+            <a:srgbClr val="FFFEF9"/>
           </a:solidFill>
           <a:ln/>
         </p:spPr>
@@ -5735,13 +5735,13 @@
         <p:spPr>
           <a:xfrm>
             <a:off x="548640" y="2651760"/>
-            <a:ext cx="73152" cy="685800"/>
-          </a:xfrm>
-          <a:prstGeom prst="rect">
-            <a:avLst/>
-          </a:prstGeom>
-          <a:solidFill>
-            <a:srgbClr val="003087"/>
+            <a:ext cx="91440" cy="685800"/>
+          </a:xfrm>
+          <a:prstGeom prst="rect">
+            <a:avLst/>
+          </a:prstGeom>
+          <a:solidFill>
+            <a:srgbClr val="2D5A27"/>
           </a:solidFill>
           <a:ln/>
         </p:spPr>
@@ -5754,14 +5754,14 @@
         </p:nvSpPr>
         <p:spPr>
           <a:xfrm>
-            <a:off x="685800" y="2811780"/>
-            <a:ext cx="365760" cy="365760"/>
+            <a:off x="667512" y="2793492"/>
+            <a:ext cx="402336" cy="402336"/>
           </a:xfrm>
           <a:prstGeom prst="ellipse">
             <a:avLst/>
           </a:prstGeom>
           <a:solidFill>
-            <a:srgbClr val="003087"/>
+            <a:srgbClr val="2D5A27"/>
           </a:solidFill>
           <a:ln/>
         </p:spPr>
@@ -5774,8 +5774,8 @@
         </p:nvSpPr>
         <p:spPr>
           <a:xfrm>
-            <a:off x="685800" y="2811780"/>
-            <a:ext cx="365760" cy="365760"/>
+            <a:off x="667512" y="2793492"/>
+            <a:ext cx="402336" cy="402336"/>
           </a:xfrm>
           <a:prstGeom prst="rect">
             <a:avLst/>
@@ -5791,9 +5791,9 @@
               <a:buNone/>
             </a:pPr>
             <a:r>
-              <a:rPr lang="en-US" sz="1100" b="1" dirty="0">
+              <a:rPr lang="en-US" sz="1200" b="1" dirty="0">
                 <a:solidFill>
-                  <a:srgbClr val="FFFFFF"/>
+                  <a:srgbClr val="FFFEF9"/>
                 </a:solidFill>
                 <a:latin typeface="Calibri" pitchFamily="34" charset="0"/>
                 <a:ea typeface="Calibri" pitchFamily="34" charset="-122"/>
@@ -5801,7 +5801,7 @@
               </a:rPr>
               <a:t>3</a:t>
             </a:r>
-            <a:endParaRPr lang="en-US" sz="1100" dirty="0"/>
+            <a:endParaRPr lang="en-US" sz="1200" dirty="0"/>
           </a:p>
         </p:txBody>
       </p:sp>
@@ -5832,7 +5832,7 @@
             <a:r>
               <a:rPr lang="en-US" sz="1400" dirty="0">
                 <a:solidFill>
-                  <a:srgbClr val="333333"/>
+                  <a:srgbClr val="3D3D3D"/>
                 </a:solidFill>
                 <a:latin typeface="Calibri" pitchFamily="34" charset="0"/>
                 <a:ea typeface="Calibri" pitchFamily="34" charset="-122"/>
@@ -5852,7 +5852,7 @@
         </p:nvSpPr>
         <p:spPr>
           <a:xfrm>
-            <a:off x="576072" y="3502152"/>
+            <a:off x="585216" y="3511296"/>
             <a:ext cx="8046720" cy="685800"/>
           </a:xfrm>
           <a:prstGeom prst="roundRect">
@@ -5861,7 +5861,7 @@
             </a:avLst>
           </a:prstGeom>
           <a:solidFill>
-            <a:srgbClr val="DDDDDD"/>
+            <a:srgbClr val="D9D4CB"/>
           </a:solidFill>
           <a:ln/>
         </p:spPr>
@@ -5883,7 +5883,7 @@
             </a:avLst>
           </a:prstGeom>
           <a:solidFill>
-            <a:srgbClr val="FFFFFF"/>
+            <a:srgbClr val="FFFEF9"/>
           </a:solidFill>
           <a:ln/>
         </p:spPr>
@@ -5897,13 +5897,13 @@
         <p:spPr>
           <a:xfrm>
             <a:off x="548640" y="3474720"/>
-            <a:ext cx="73152" cy="685800"/>
-          </a:xfrm>
-          <a:prstGeom prst="rect">
-            <a:avLst/>
-          </a:prstGeom>
-          <a:solidFill>
-            <a:srgbClr val="003087"/>
+            <a:ext cx="91440" cy="685800"/>
+          </a:xfrm>
+          <a:prstGeom prst="rect">
+            <a:avLst/>
+          </a:prstGeom>
+          <a:solidFill>
+            <a:srgbClr val="2D5A27"/>
           </a:solidFill>
           <a:ln/>
         </p:spPr>
@@ -5916,14 +5916,14 @@
         </p:nvSpPr>
         <p:spPr>
           <a:xfrm>
-            <a:off x="685800" y="3634740"/>
-            <a:ext cx="365760" cy="365760"/>
+            <a:off x="667512" y="3616452"/>
+            <a:ext cx="402336" cy="402336"/>
           </a:xfrm>
           <a:prstGeom prst="ellipse">
             <a:avLst/>
           </a:prstGeom>
           <a:solidFill>
-            <a:srgbClr val="003087"/>
+            <a:srgbClr val="2D5A27"/>
           </a:solidFill>
           <a:ln/>
         </p:spPr>
@@ -5936,8 +5936,8 @@
         </p:nvSpPr>
         <p:spPr>
           <a:xfrm>
-            <a:off x="685800" y="3634740"/>
-            <a:ext cx="365760" cy="365760"/>
+            <a:off x="667512" y="3616452"/>
+            <a:ext cx="402336" cy="402336"/>
           </a:xfrm>
           <a:prstGeom prst="rect">
             <a:avLst/>
@@ -5953,9 +5953,9 @@
               <a:buNone/>
             </a:pPr>
             <a:r>
-              <a:rPr lang="en-US" sz="1100" b="1" dirty="0">
+              <a:rPr lang="en-US" sz="1200" b="1" dirty="0">
                 <a:solidFill>
-                  <a:srgbClr val="FFFFFF"/>
+                  <a:srgbClr val="FFFEF9"/>
                 </a:solidFill>
                 <a:latin typeface="Calibri" pitchFamily="34" charset="0"/>
                 <a:ea typeface="Calibri" pitchFamily="34" charset="-122"/>
@@ -5963,7 +5963,7 @@
               </a:rPr>
               <a:t>4</a:t>
             </a:r>
-            <a:endParaRPr lang="en-US" sz="1100" dirty="0"/>
+            <a:endParaRPr lang="en-US" sz="1200" dirty="0"/>
           </a:p>
         </p:txBody>
       </p:sp>
@@ -5994,7 +5994,7 @@
             <a:r>
               <a:rPr lang="en-US" sz="1400" dirty="0">
                 <a:solidFill>
-                  <a:srgbClr val="333333"/>
+                  <a:srgbClr val="3D3D3D"/>
                 </a:solidFill>
                 <a:latin typeface="Calibri" pitchFamily="34" charset="0"/>
                 <a:ea typeface="Calibri" pitchFamily="34" charset="-122"/>
@@ -6020,7 +6020,7 @@
     <p:bg>
       <p:bgPr>
         <a:solidFill>
-          <a:srgbClr val="F5F5F5"/>
+          <a:srgbClr val="FDF8F3"/>
         </a:solidFill>
       </p:bgPr>
     </p:bg>
@@ -6065,7 +6065,7 @@
             <a:r>
               <a:rPr lang="en-US" sz="2600" b="1" dirty="0">
                 <a:solidFill>
-                  <a:srgbClr val="003087"/>
+                  <a:srgbClr val="2D5A27"/>
                 </a:solidFill>
                 <a:latin typeface="Georgia" pitchFamily="34" charset="0"/>
                 <a:ea typeface="Georgia" pitchFamily="34" charset="-122"/>
@@ -6092,7 +6092,7 @@
             <a:avLst/>
           </a:prstGeom>
           <a:solidFill>
-            <a:srgbClr val="E67E22"/>
+            <a:srgbClr val="D4A574"/>
           </a:solidFill>
           <a:ln/>
         </p:spPr>
@@ -6114,7 +6114,7 @@
             </a:avLst>
           </a:prstGeom>
           <a:solidFill>
-            <a:srgbClr val="003087"/>
+            <a:srgbClr val="2D5A27"/>
           </a:solidFill>
           <a:ln/>
         </p:spPr>
@@ -6146,7 +6146,7 @@
             <a:r>
               <a:rPr lang="en-US" sz="1300" i="1" dirty="0">
                 <a:solidFill>
-                  <a:srgbClr val="FFFFFF"/>
+                  <a:srgbClr val="FFFEF9"/>
                 </a:solidFill>
                 <a:latin typeface="Calibri" pitchFamily="34" charset="0"/>
                 <a:ea typeface="Calibri" pitchFamily="34" charset="-122"/>
@@ -6175,7 +6175,7 @@
             </a:avLst>
           </a:prstGeom>
           <a:solidFill>
-            <a:srgbClr val="003087"/>
+            <a:srgbClr val="2D5A27"/>
           </a:solidFill>
           <a:ln/>
         </p:spPr>
@@ -6207,7 +6207,7 @@
             <a:r>
               <a:rPr lang="en-US" sz="1300" i="1" dirty="0">
                 <a:solidFill>
-                  <a:srgbClr val="FFFFFF"/>
+                  <a:srgbClr val="FFFEF9"/>
                 </a:solidFill>
                 <a:latin typeface="Calibri" pitchFamily="34" charset="0"/>
                 <a:ea typeface="Calibri" pitchFamily="34" charset="-122"/>
@@ -6233,7 +6233,7 @@
     <p:bg>
       <p:bgPr>
         <a:solidFill>
-          <a:srgbClr val="F5F5F5"/>
+          <a:srgbClr val="FDF8F3"/>
         </a:solidFill>
       </p:bgPr>
     </p:bg>
@@ -6278,7 +6278,7 @@
             <a:r>
               <a:rPr lang="en-US" sz="2600" b="1" dirty="0">
                 <a:solidFill>
-                  <a:srgbClr val="003087"/>
+                  <a:srgbClr val="2D5A27"/>
                 </a:solidFill>
                 <a:latin typeface="Georgia" pitchFamily="34" charset="0"/>
                 <a:ea typeface="Georgia" pitchFamily="34" charset="-122"/>
@@ -6305,7 +6305,7 @@
             <a:avLst/>
           </a:prstGeom>
           <a:solidFill>
-            <a:srgbClr val="E67E22"/>
+            <a:srgbClr val="D4A574"/>
           </a:solidFill>
           <a:ln/>
         </p:spPr>

</xml_diff>